<commit_message>
V3: increase font sizes - body 14pt, section headers 16pt
Co-Authored-By: Claude <noreply@anthropic.com>
</commit_message>
<xml_diff>
--- a/ppts_output_v3/04_消费税风险指引.pptx
+++ b/ppts_output_v3/04_消费税风险指引.pptx
@@ -3310,7 +3310,7 @@
           <a:p>
             <a:pPr algn="l">
               <a:lnSpc>
-                <a:spcPts val="1820"/>
+                <a:spcPts val="2080"/>
               </a:lnSpc>
               <a:spcBef>
                 <a:spcPts val="0"/>
@@ -3320,7 +3320,7 @@
               </a:spcAft>
             </a:pPr>
             <a:r>
-              <a:rPr sz="1400" b="1">
+              <a:rPr sz="1600" b="1">
                 <a:solidFill>
                   <a:srgbClr val="1B3A5C"/>
                 </a:solidFill>
@@ -3332,7 +3332,7 @@
           <a:p>
             <a:pPr algn="l">
               <a:lnSpc>
-                <a:spcPts val="1820"/>
+                <a:spcPts val="2080"/>
               </a:lnSpc>
               <a:spcBef>
                 <a:spcPts val="800"/>
@@ -3342,7 +3342,7 @@
               </a:spcAft>
             </a:pPr>
             <a:r>
-              <a:rPr sz="1400" b="1">
+              <a:rPr sz="1600" b="1">
                 <a:solidFill>
                   <a:srgbClr val="333333"/>
                 </a:solidFill>
@@ -3354,17 +3354,17 @@
           <a:p>
             <a:pPr algn="l">
               <a:lnSpc>
-                <a:spcPts val="1430"/>
-              </a:lnSpc>
-              <a:spcBef>
-                <a:spcPts val="200"/>
-              </a:spcBef>
-              <a:spcAft>
-                <a:spcPts val="200"/>
-              </a:spcAft>
-            </a:pPr>
-            <a:r>
-              <a:rPr sz="1100" b="0">
+                <a:spcPts val="1820"/>
+              </a:lnSpc>
+              <a:spcBef>
+                <a:spcPts val="200"/>
+              </a:spcBef>
+              <a:spcAft>
+                <a:spcPts val="200"/>
+              </a:spcAft>
+            </a:pPr>
+            <a:r>
+              <a:rPr sz="1400" b="0">
                 <a:solidFill>
                   <a:srgbClr val="000000"/>
                 </a:solidFill>
@@ -3376,7 +3376,7 @@
           <a:p>
             <a:pPr algn="l">
               <a:lnSpc>
-                <a:spcPts val="1820"/>
+                <a:spcPts val="2080"/>
               </a:lnSpc>
               <a:spcBef>
                 <a:spcPts val="800"/>
@@ -3386,7 +3386,7 @@
               </a:spcAft>
             </a:pPr>
             <a:r>
-              <a:rPr sz="1400" b="1">
+              <a:rPr sz="1600" b="1">
                 <a:solidFill>
                   <a:srgbClr val="1B5C9E"/>
                 </a:solidFill>
@@ -3398,17 +3398,17 @@
           <a:p>
             <a:pPr algn="l">
               <a:lnSpc>
-                <a:spcPts val="1430"/>
-              </a:lnSpc>
-              <a:spcBef>
-                <a:spcPts val="200"/>
-              </a:spcBef>
-              <a:spcAft>
-                <a:spcPts val="200"/>
-              </a:spcAft>
-            </a:pPr>
-            <a:r>
-              <a:rPr sz="1100" b="0">
+                <a:spcPts val="1820"/>
+              </a:lnSpc>
+              <a:spcBef>
+                <a:spcPts val="200"/>
+              </a:spcBef>
+              <a:spcAft>
+                <a:spcPts val="200"/>
+              </a:spcAft>
+            </a:pPr>
+            <a:r>
+              <a:rPr sz="1400" b="0">
                 <a:solidFill>
                   <a:srgbClr val="000000"/>
                 </a:solidFill>
@@ -3420,17 +3420,17 @@
           <a:p>
             <a:pPr algn="l">
               <a:lnSpc>
-                <a:spcPts val="1430"/>
-              </a:lnSpc>
-              <a:spcBef>
-                <a:spcPts val="200"/>
-              </a:spcBef>
-              <a:spcAft>
-                <a:spcPts val="200"/>
-              </a:spcAft>
-            </a:pPr>
-            <a:r>
-              <a:rPr sz="1100" b="0">
+                <a:spcPts val="1820"/>
+              </a:lnSpc>
+              <a:spcBef>
+                <a:spcPts val="200"/>
+              </a:spcBef>
+              <a:spcAft>
+                <a:spcPts val="200"/>
+              </a:spcAft>
+            </a:pPr>
+            <a:r>
+              <a:rPr sz="1400" b="0">
                 <a:solidFill>
                   <a:srgbClr val="000000"/>
                 </a:solidFill>
@@ -3442,17 +3442,17 @@
           <a:p>
             <a:pPr algn="l">
               <a:lnSpc>
-                <a:spcPts val="1430"/>
-              </a:lnSpc>
-              <a:spcBef>
-                <a:spcPts val="200"/>
-              </a:spcBef>
-              <a:spcAft>
-                <a:spcPts val="200"/>
-              </a:spcAft>
-            </a:pPr>
-            <a:r>
-              <a:rPr sz="1100" b="0">
+                <a:spcPts val="1820"/>
+              </a:lnSpc>
+              <a:spcBef>
+                <a:spcPts val="200"/>
+              </a:spcBef>
+              <a:spcAft>
+                <a:spcPts val="200"/>
+              </a:spcAft>
+            </a:pPr>
+            <a:r>
+              <a:rPr sz="1400" b="0">
                 <a:solidFill>
                   <a:srgbClr val="000000"/>
                 </a:solidFill>
@@ -3464,7 +3464,7 @@
           <a:p>
             <a:pPr algn="l">
               <a:lnSpc>
-                <a:spcPts val="1820"/>
+                <a:spcPts val="2080"/>
               </a:lnSpc>
               <a:spcBef>
                 <a:spcPts val="800"/>
@@ -3474,7 +3474,7 @@
               </a:spcAft>
             </a:pPr>
             <a:r>
-              <a:rPr sz="1400" b="1">
+              <a:rPr sz="1600" b="1">
                 <a:solidFill>
                   <a:srgbClr val="CC3333"/>
                 </a:solidFill>
@@ -3486,17 +3486,17 @@
           <a:p>
             <a:pPr algn="l">
               <a:lnSpc>
-                <a:spcPts val="1430"/>
-              </a:lnSpc>
-              <a:spcBef>
-                <a:spcPts val="200"/>
-              </a:spcBef>
-              <a:spcAft>
-                <a:spcPts val="200"/>
-              </a:spcAft>
-            </a:pPr>
-            <a:r>
-              <a:rPr sz="1100" b="0">
+                <a:spcPts val="1820"/>
+              </a:lnSpc>
+              <a:spcBef>
+                <a:spcPts val="200"/>
+              </a:spcBef>
+              <a:spcAft>
+                <a:spcPts val="200"/>
+              </a:spcAft>
+            </a:pPr>
+            <a:r>
+              <a:rPr sz="1400" b="0">
                 <a:solidFill>
                   <a:srgbClr val="000000"/>
                 </a:solidFill>
@@ -3508,7 +3508,7 @@
           <a:p>
             <a:pPr algn="l">
               <a:lnSpc>
-                <a:spcPts val="1820"/>
+                <a:spcPts val="2080"/>
               </a:lnSpc>
               <a:spcBef>
                 <a:spcPts val="800"/>
@@ -3518,7 +3518,7 @@
               </a:spcAft>
             </a:pPr>
             <a:r>
-              <a:rPr sz="1400" b="1">
+              <a:rPr sz="1600" b="1">
                 <a:solidFill>
                   <a:srgbClr val="008040"/>
                 </a:solidFill>
@@ -3530,17 +3530,17 @@
           <a:p>
             <a:pPr algn="l">
               <a:lnSpc>
-                <a:spcPts val="1430"/>
-              </a:lnSpc>
-              <a:spcBef>
-                <a:spcPts val="200"/>
-              </a:spcBef>
-              <a:spcAft>
-                <a:spcPts val="200"/>
-              </a:spcAft>
-            </a:pPr>
-            <a:r>
-              <a:rPr sz="1100" b="0">
+                <a:spcPts val="1820"/>
+              </a:lnSpc>
+              <a:spcBef>
+                <a:spcPts val="200"/>
+              </a:spcBef>
+              <a:spcAft>
+                <a:spcPts val="200"/>
+              </a:spcAft>
+            </a:pPr>
+            <a:r>
+              <a:rPr sz="1400" b="0">
                 <a:solidFill>
                   <a:srgbClr val="000000"/>
                 </a:solidFill>
@@ -3645,7 +3645,7 @@
           <a:p>
             <a:pPr algn="l">
               <a:lnSpc>
-                <a:spcPts val="1820"/>
+                <a:spcPts val="2080"/>
               </a:lnSpc>
               <a:spcBef>
                 <a:spcPts val="0"/>
@@ -3655,7 +3655,7 @@
               </a:spcAft>
             </a:pPr>
             <a:r>
-              <a:rPr sz="1400" b="1">
+              <a:rPr sz="1600" b="1">
                 <a:solidFill>
                   <a:srgbClr val="1B3A5C"/>
                 </a:solidFill>
@@ -3667,7 +3667,7 @@
           <a:p>
             <a:pPr algn="l">
               <a:lnSpc>
-                <a:spcPts val="1820"/>
+                <a:spcPts val="2080"/>
               </a:lnSpc>
               <a:spcBef>
                 <a:spcPts val="800"/>
@@ -3677,7 +3677,7 @@
               </a:spcAft>
             </a:pPr>
             <a:r>
-              <a:rPr sz="1400" b="1">
+              <a:rPr sz="1600" b="1">
                 <a:solidFill>
                   <a:srgbClr val="333333"/>
                 </a:solidFill>
@@ -3689,17 +3689,17 @@
           <a:p>
             <a:pPr algn="l">
               <a:lnSpc>
-                <a:spcPts val="1430"/>
-              </a:lnSpc>
-              <a:spcBef>
-                <a:spcPts val="200"/>
-              </a:spcBef>
-              <a:spcAft>
-                <a:spcPts val="200"/>
-              </a:spcAft>
-            </a:pPr>
-            <a:r>
-              <a:rPr sz="1100" b="0">
+                <a:spcPts val="1820"/>
+              </a:lnSpc>
+              <a:spcBef>
+                <a:spcPts val="200"/>
+              </a:spcBef>
+              <a:spcAft>
+                <a:spcPts val="200"/>
+              </a:spcAft>
+            </a:pPr>
+            <a:r>
+              <a:rPr sz="1400" b="0">
                 <a:solidFill>
                   <a:srgbClr val="000000"/>
                 </a:solidFill>
@@ -3711,7 +3711,7 @@
           <a:p>
             <a:pPr algn="l">
               <a:lnSpc>
-                <a:spcPts val="1820"/>
+                <a:spcPts val="2080"/>
               </a:lnSpc>
               <a:spcBef>
                 <a:spcPts val="800"/>
@@ -3721,7 +3721,7 @@
               </a:spcAft>
             </a:pPr>
             <a:r>
-              <a:rPr sz="1400" b="1">
+              <a:rPr sz="1600" b="1">
                 <a:solidFill>
                   <a:srgbClr val="1B5C9E"/>
                 </a:solidFill>
@@ -3733,17 +3733,17 @@
           <a:p>
             <a:pPr algn="l">
               <a:lnSpc>
-                <a:spcPts val="1430"/>
-              </a:lnSpc>
-              <a:spcBef>
-                <a:spcPts val="200"/>
-              </a:spcBef>
-              <a:spcAft>
-                <a:spcPts val="200"/>
-              </a:spcAft>
-            </a:pPr>
-            <a:r>
-              <a:rPr sz="1100" b="0">
+                <a:spcPts val="1820"/>
+              </a:lnSpc>
+              <a:spcBef>
+                <a:spcPts val="200"/>
+              </a:spcBef>
+              <a:spcAft>
+                <a:spcPts val="200"/>
+              </a:spcAft>
+            </a:pPr>
+            <a:r>
+              <a:rPr sz="1400" b="0">
                 <a:solidFill>
                   <a:srgbClr val="000000"/>
                 </a:solidFill>
@@ -3755,7 +3755,7 @@
           <a:p>
             <a:pPr algn="l">
               <a:lnSpc>
-                <a:spcPts val="1820"/>
+                <a:spcPts val="2080"/>
               </a:lnSpc>
               <a:spcBef>
                 <a:spcPts val="800"/>
@@ -3765,7 +3765,7 @@
               </a:spcAft>
             </a:pPr>
             <a:r>
-              <a:rPr sz="1400" b="1">
+              <a:rPr sz="1600" b="1">
                 <a:solidFill>
                   <a:srgbClr val="CC3333"/>
                 </a:solidFill>
@@ -3777,17 +3777,17 @@
           <a:p>
             <a:pPr algn="l">
               <a:lnSpc>
-                <a:spcPts val="1430"/>
-              </a:lnSpc>
-              <a:spcBef>
-                <a:spcPts val="200"/>
-              </a:spcBef>
-              <a:spcAft>
-                <a:spcPts val="200"/>
-              </a:spcAft>
-            </a:pPr>
-            <a:r>
-              <a:rPr sz="1100" b="0">
+                <a:spcPts val="1820"/>
+              </a:lnSpc>
+              <a:spcBef>
+                <a:spcPts val="200"/>
+              </a:spcBef>
+              <a:spcAft>
+                <a:spcPts val="200"/>
+              </a:spcAft>
+            </a:pPr>
+            <a:r>
+              <a:rPr sz="1400" b="0">
                 <a:solidFill>
                   <a:srgbClr val="000000"/>
                 </a:solidFill>
@@ -3799,7 +3799,7 @@
           <a:p>
             <a:pPr algn="l">
               <a:lnSpc>
-                <a:spcPts val="1820"/>
+                <a:spcPts val="2080"/>
               </a:lnSpc>
               <a:spcBef>
                 <a:spcPts val="800"/>
@@ -3809,7 +3809,7 @@
               </a:spcAft>
             </a:pPr>
             <a:r>
-              <a:rPr sz="1400" b="1">
+              <a:rPr sz="1600" b="1">
                 <a:solidFill>
                   <a:srgbClr val="008040"/>
                 </a:solidFill>
@@ -3821,17 +3821,17 @@
           <a:p>
             <a:pPr algn="l">
               <a:lnSpc>
-                <a:spcPts val="1430"/>
-              </a:lnSpc>
-              <a:spcBef>
-                <a:spcPts val="200"/>
-              </a:spcBef>
-              <a:spcAft>
-                <a:spcPts val="200"/>
-              </a:spcAft>
-            </a:pPr>
-            <a:r>
-              <a:rPr sz="1100" b="0">
+                <a:spcPts val="1820"/>
+              </a:lnSpc>
+              <a:spcBef>
+                <a:spcPts val="200"/>
+              </a:spcBef>
+              <a:spcAft>
+                <a:spcPts val="200"/>
+              </a:spcAft>
+            </a:pPr>
+            <a:r>
+              <a:rPr sz="1400" b="0">
                 <a:solidFill>
                   <a:srgbClr val="000000"/>
                 </a:solidFill>
@@ -3936,7 +3936,7 @@
           <a:p>
             <a:pPr algn="l">
               <a:lnSpc>
-                <a:spcPts val="1820"/>
+                <a:spcPts val="2080"/>
               </a:lnSpc>
               <a:spcBef>
                 <a:spcPts val="0"/>
@@ -3946,7 +3946,7 @@
               </a:spcAft>
             </a:pPr>
             <a:r>
-              <a:rPr sz="1400" b="1">
+              <a:rPr sz="1600" b="1">
                 <a:solidFill>
                   <a:srgbClr val="1B3A5C"/>
                 </a:solidFill>
@@ -3958,7 +3958,7 @@
           <a:p>
             <a:pPr algn="l">
               <a:lnSpc>
-                <a:spcPts val="1820"/>
+                <a:spcPts val="2080"/>
               </a:lnSpc>
               <a:spcBef>
                 <a:spcPts val="800"/>
@@ -3968,7 +3968,7 @@
               </a:spcAft>
             </a:pPr>
             <a:r>
-              <a:rPr sz="1400" b="1">
+              <a:rPr sz="1600" b="1">
                 <a:solidFill>
                   <a:srgbClr val="333333"/>
                 </a:solidFill>
@@ -3980,17 +3980,17 @@
           <a:p>
             <a:pPr algn="l">
               <a:lnSpc>
-                <a:spcPts val="1430"/>
-              </a:lnSpc>
-              <a:spcBef>
-                <a:spcPts val="200"/>
-              </a:spcBef>
-              <a:spcAft>
-                <a:spcPts val="200"/>
-              </a:spcAft>
-            </a:pPr>
-            <a:r>
-              <a:rPr sz="1100" b="0">
+                <a:spcPts val="1820"/>
+              </a:lnSpc>
+              <a:spcBef>
+                <a:spcPts val="200"/>
+              </a:spcBef>
+              <a:spcAft>
+                <a:spcPts val="200"/>
+              </a:spcAft>
+            </a:pPr>
+            <a:r>
+              <a:rPr sz="1400" b="0">
                 <a:solidFill>
                   <a:srgbClr val="000000"/>
                 </a:solidFill>
@@ -4002,7 +4002,7 @@
           <a:p>
             <a:pPr algn="l">
               <a:lnSpc>
-                <a:spcPts val="1820"/>
+                <a:spcPts val="2080"/>
               </a:lnSpc>
               <a:spcBef>
                 <a:spcPts val="800"/>
@@ -4012,7 +4012,7 @@
               </a:spcAft>
             </a:pPr>
             <a:r>
-              <a:rPr sz="1400" b="1">
+              <a:rPr sz="1600" b="1">
                 <a:solidFill>
                   <a:srgbClr val="1B5C9E"/>
                 </a:solidFill>
@@ -4024,17 +4024,17 @@
           <a:p>
             <a:pPr algn="l">
               <a:lnSpc>
-                <a:spcPts val="1430"/>
-              </a:lnSpc>
-              <a:spcBef>
-                <a:spcPts val="200"/>
-              </a:spcBef>
-              <a:spcAft>
-                <a:spcPts val="200"/>
-              </a:spcAft>
-            </a:pPr>
-            <a:r>
-              <a:rPr sz="1100" b="0">
+                <a:spcPts val="1820"/>
+              </a:lnSpc>
+              <a:spcBef>
+                <a:spcPts val="200"/>
+              </a:spcBef>
+              <a:spcAft>
+                <a:spcPts val="200"/>
+              </a:spcAft>
+            </a:pPr>
+            <a:r>
+              <a:rPr sz="1400" b="0">
                 <a:solidFill>
                   <a:srgbClr val="000000"/>
                 </a:solidFill>
@@ -4046,17 +4046,17 @@
           <a:p>
             <a:pPr algn="l">
               <a:lnSpc>
-                <a:spcPts val="1430"/>
-              </a:lnSpc>
-              <a:spcBef>
-                <a:spcPts val="200"/>
-              </a:spcBef>
-              <a:spcAft>
-                <a:spcPts val="200"/>
-              </a:spcAft>
-            </a:pPr>
-            <a:r>
-              <a:rPr sz="1100" b="0">
+                <a:spcPts val="1820"/>
+              </a:lnSpc>
+              <a:spcBef>
+                <a:spcPts val="200"/>
+              </a:spcBef>
+              <a:spcAft>
+                <a:spcPts val="200"/>
+              </a:spcAft>
+            </a:pPr>
+            <a:r>
+              <a:rPr sz="1400" b="0">
                 <a:solidFill>
                   <a:srgbClr val="000000"/>
                 </a:solidFill>
@@ -4068,7 +4068,7 @@
           <a:p>
             <a:pPr algn="l">
               <a:lnSpc>
-                <a:spcPts val="1820"/>
+                <a:spcPts val="2080"/>
               </a:lnSpc>
               <a:spcBef>
                 <a:spcPts val="800"/>
@@ -4078,7 +4078,7 @@
               </a:spcAft>
             </a:pPr>
             <a:r>
-              <a:rPr sz="1400" b="1">
+              <a:rPr sz="1600" b="1">
                 <a:solidFill>
                   <a:srgbClr val="CC3333"/>
                 </a:solidFill>
@@ -4090,17 +4090,17 @@
           <a:p>
             <a:pPr algn="l">
               <a:lnSpc>
-                <a:spcPts val="1430"/>
-              </a:lnSpc>
-              <a:spcBef>
-                <a:spcPts val="200"/>
-              </a:spcBef>
-              <a:spcAft>
-                <a:spcPts val="200"/>
-              </a:spcAft>
-            </a:pPr>
-            <a:r>
-              <a:rPr sz="1100" b="0">
+                <a:spcPts val="1820"/>
+              </a:lnSpc>
+              <a:spcBef>
+                <a:spcPts val="200"/>
+              </a:spcBef>
+              <a:spcAft>
+                <a:spcPts val="200"/>
+              </a:spcAft>
+            </a:pPr>
+            <a:r>
+              <a:rPr sz="1400" b="0">
                 <a:solidFill>
                   <a:srgbClr val="000000"/>
                 </a:solidFill>
@@ -4112,7 +4112,7 @@
           <a:p>
             <a:pPr algn="l">
               <a:lnSpc>
-                <a:spcPts val="1820"/>
+                <a:spcPts val="2080"/>
               </a:lnSpc>
               <a:spcBef>
                 <a:spcPts val="800"/>
@@ -4122,7 +4122,7 @@
               </a:spcAft>
             </a:pPr>
             <a:r>
-              <a:rPr sz="1400" b="1">
+              <a:rPr sz="1600" b="1">
                 <a:solidFill>
                   <a:srgbClr val="008040"/>
                 </a:solidFill>
@@ -4134,17 +4134,17 @@
           <a:p>
             <a:pPr algn="l">
               <a:lnSpc>
-                <a:spcPts val="1430"/>
-              </a:lnSpc>
-              <a:spcBef>
-                <a:spcPts val="200"/>
-              </a:spcBef>
-              <a:spcAft>
-                <a:spcPts val="200"/>
-              </a:spcAft>
-            </a:pPr>
-            <a:r>
-              <a:rPr sz="1100" b="0">
+                <a:spcPts val="1820"/>
+              </a:lnSpc>
+              <a:spcBef>
+                <a:spcPts val="200"/>
+              </a:spcBef>
+              <a:spcAft>
+                <a:spcPts val="200"/>
+              </a:spcAft>
+            </a:pPr>
+            <a:r>
+              <a:rPr sz="1400" b="0">
                 <a:solidFill>
                   <a:srgbClr val="000000"/>
                 </a:solidFill>
@@ -4249,7 +4249,7 @@
           <a:p>
             <a:pPr algn="l">
               <a:lnSpc>
-                <a:spcPts val="1820"/>
+                <a:spcPts val="2080"/>
               </a:lnSpc>
               <a:spcBef>
                 <a:spcPts val="0"/>
@@ -4259,7 +4259,7 @@
               </a:spcAft>
             </a:pPr>
             <a:r>
-              <a:rPr sz="1400" b="1">
+              <a:rPr sz="1600" b="1">
                 <a:solidFill>
                   <a:srgbClr val="1B3A5C"/>
                 </a:solidFill>
@@ -4271,7 +4271,7 @@
           <a:p>
             <a:pPr algn="l">
               <a:lnSpc>
-                <a:spcPts val="1820"/>
+                <a:spcPts val="2080"/>
               </a:lnSpc>
               <a:spcBef>
                 <a:spcPts val="800"/>
@@ -4281,7 +4281,7 @@
               </a:spcAft>
             </a:pPr>
             <a:r>
-              <a:rPr sz="1400" b="1">
+              <a:rPr sz="1600" b="1">
                 <a:solidFill>
                   <a:srgbClr val="333333"/>
                 </a:solidFill>
@@ -4293,17 +4293,17 @@
           <a:p>
             <a:pPr algn="l">
               <a:lnSpc>
-                <a:spcPts val="1430"/>
-              </a:lnSpc>
-              <a:spcBef>
-                <a:spcPts val="200"/>
-              </a:spcBef>
-              <a:spcAft>
-                <a:spcPts val="200"/>
-              </a:spcAft>
-            </a:pPr>
-            <a:r>
-              <a:rPr sz="1100" b="0">
+                <a:spcPts val="1820"/>
+              </a:lnSpc>
+              <a:spcBef>
+                <a:spcPts val="200"/>
+              </a:spcBef>
+              <a:spcAft>
+                <a:spcPts val="200"/>
+              </a:spcAft>
+            </a:pPr>
+            <a:r>
+              <a:rPr sz="1400" b="0">
                 <a:solidFill>
                   <a:srgbClr val="000000"/>
                 </a:solidFill>
@@ -4315,7 +4315,7 @@
           <a:p>
             <a:pPr algn="l">
               <a:lnSpc>
-                <a:spcPts val="1820"/>
+                <a:spcPts val="2080"/>
               </a:lnSpc>
               <a:spcBef>
                 <a:spcPts val="800"/>
@@ -4325,7 +4325,7 @@
               </a:spcAft>
             </a:pPr>
             <a:r>
-              <a:rPr sz="1400" b="1">
+              <a:rPr sz="1600" b="1">
                 <a:solidFill>
                   <a:srgbClr val="1B5C9E"/>
                 </a:solidFill>
@@ -4337,17 +4337,17 @@
           <a:p>
             <a:pPr algn="l">
               <a:lnSpc>
-                <a:spcPts val="1430"/>
-              </a:lnSpc>
-              <a:spcBef>
-                <a:spcPts val="200"/>
-              </a:spcBef>
-              <a:spcAft>
-                <a:spcPts val="200"/>
-              </a:spcAft>
-            </a:pPr>
-            <a:r>
-              <a:rPr sz="1100" b="0">
+                <a:spcPts val="1820"/>
+              </a:lnSpc>
+              <a:spcBef>
+                <a:spcPts val="200"/>
+              </a:spcBef>
+              <a:spcAft>
+                <a:spcPts val="200"/>
+              </a:spcAft>
+            </a:pPr>
+            <a:r>
+              <a:rPr sz="1400" b="0">
                 <a:solidFill>
                   <a:srgbClr val="000000"/>
                 </a:solidFill>
@@ -4359,7 +4359,7 @@
           <a:p>
             <a:pPr algn="l">
               <a:lnSpc>
-                <a:spcPts val="1820"/>
+                <a:spcPts val="2080"/>
               </a:lnSpc>
               <a:spcBef>
                 <a:spcPts val="800"/>
@@ -4369,7 +4369,7 @@
               </a:spcAft>
             </a:pPr>
             <a:r>
-              <a:rPr sz="1400" b="1">
+              <a:rPr sz="1600" b="1">
                 <a:solidFill>
                   <a:srgbClr val="CC3333"/>
                 </a:solidFill>
@@ -4381,17 +4381,17 @@
           <a:p>
             <a:pPr algn="l">
               <a:lnSpc>
-                <a:spcPts val="1430"/>
-              </a:lnSpc>
-              <a:spcBef>
-                <a:spcPts val="200"/>
-              </a:spcBef>
-              <a:spcAft>
-                <a:spcPts val="200"/>
-              </a:spcAft>
-            </a:pPr>
-            <a:r>
-              <a:rPr sz="1100" b="0">
+                <a:spcPts val="1820"/>
+              </a:lnSpc>
+              <a:spcBef>
+                <a:spcPts val="200"/>
+              </a:spcBef>
+              <a:spcAft>
+                <a:spcPts val="200"/>
+              </a:spcAft>
+            </a:pPr>
+            <a:r>
+              <a:rPr sz="1400" b="0">
                 <a:solidFill>
                   <a:srgbClr val="000000"/>
                 </a:solidFill>
@@ -4403,7 +4403,7 @@
           <a:p>
             <a:pPr algn="l">
               <a:lnSpc>
-                <a:spcPts val="1820"/>
+                <a:spcPts val="2080"/>
               </a:lnSpc>
               <a:spcBef>
                 <a:spcPts val="800"/>
@@ -4413,7 +4413,7 @@
               </a:spcAft>
             </a:pPr>
             <a:r>
-              <a:rPr sz="1400" b="1">
+              <a:rPr sz="1600" b="1">
                 <a:solidFill>
                   <a:srgbClr val="008040"/>
                 </a:solidFill>
@@ -4425,17 +4425,17 @@
           <a:p>
             <a:pPr algn="l">
               <a:lnSpc>
-                <a:spcPts val="1430"/>
-              </a:lnSpc>
-              <a:spcBef>
-                <a:spcPts val="200"/>
-              </a:spcBef>
-              <a:spcAft>
-                <a:spcPts val="200"/>
-              </a:spcAft>
-            </a:pPr>
-            <a:r>
-              <a:rPr sz="1100" b="0">
+                <a:spcPts val="1820"/>
+              </a:lnSpc>
+              <a:spcBef>
+                <a:spcPts val="200"/>
+              </a:spcBef>
+              <a:spcAft>
+                <a:spcPts val="200"/>
+              </a:spcAft>
+            </a:pPr>
+            <a:r>
+              <a:rPr sz="1400" b="0">
                 <a:solidFill>
                   <a:srgbClr val="000000"/>
                 </a:solidFill>
@@ -4540,7 +4540,7 @@
           <a:p>
             <a:pPr algn="l">
               <a:lnSpc>
-                <a:spcPts val="1820"/>
+                <a:spcPts val="2080"/>
               </a:lnSpc>
               <a:spcBef>
                 <a:spcPts val="0"/>
@@ -4550,7 +4550,7 @@
               </a:spcAft>
             </a:pPr>
             <a:r>
-              <a:rPr sz="1400" b="1">
+              <a:rPr sz="1600" b="1">
                 <a:solidFill>
                   <a:srgbClr val="1B3A5C"/>
                 </a:solidFill>
@@ -4562,7 +4562,7 @@
           <a:p>
             <a:pPr algn="l">
               <a:lnSpc>
-                <a:spcPts val="1820"/>
+                <a:spcPts val="2080"/>
               </a:lnSpc>
               <a:spcBef>
                 <a:spcPts val="800"/>
@@ -4572,7 +4572,7 @@
               </a:spcAft>
             </a:pPr>
             <a:r>
-              <a:rPr sz="1400" b="1">
+              <a:rPr sz="1600" b="1">
                 <a:solidFill>
                   <a:srgbClr val="333333"/>
                 </a:solidFill>
@@ -4584,17 +4584,17 @@
           <a:p>
             <a:pPr algn="l">
               <a:lnSpc>
-                <a:spcPts val="1430"/>
-              </a:lnSpc>
-              <a:spcBef>
-                <a:spcPts val="200"/>
-              </a:spcBef>
-              <a:spcAft>
-                <a:spcPts val="200"/>
-              </a:spcAft>
-            </a:pPr>
-            <a:r>
-              <a:rPr sz="1100" b="0">
+                <a:spcPts val="1820"/>
+              </a:lnSpc>
+              <a:spcBef>
+                <a:spcPts val="200"/>
+              </a:spcBef>
+              <a:spcAft>
+                <a:spcPts val="200"/>
+              </a:spcAft>
+            </a:pPr>
+            <a:r>
+              <a:rPr sz="1400" b="0">
                 <a:solidFill>
                   <a:srgbClr val="000000"/>
                 </a:solidFill>
@@ -4606,7 +4606,7 @@
           <a:p>
             <a:pPr algn="l">
               <a:lnSpc>
-                <a:spcPts val="1820"/>
+                <a:spcPts val="2080"/>
               </a:lnSpc>
               <a:spcBef>
                 <a:spcPts val="800"/>
@@ -4616,7 +4616,7 @@
               </a:spcAft>
             </a:pPr>
             <a:r>
-              <a:rPr sz="1400" b="1">
+              <a:rPr sz="1600" b="1">
                 <a:solidFill>
                   <a:srgbClr val="1B5C9E"/>
                 </a:solidFill>
@@ -4628,17 +4628,17 @@
           <a:p>
             <a:pPr algn="l">
               <a:lnSpc>
-                <a:spcPts val="1430"/>
-              </a:lnSpc>
-              <a:spcBef>
-                <a:spcPts val="200"/>
-              </a:spcBef>
-              <a:spcAft>
-                <a:spcPts val="200"/>
-              </a:spcAft>
-            </a:pPr>
-            <a:r>
-              <a:rPr sz="1100" b="0">
+                <a:spcPts val="1820"/>
+              </a:lnSpc>
+              <a:spcBef>
+                <a:spcPts val="200"/>
+              </a:spcBef>
+              <a:spcAft>
+                <a:spcPts val="200"/>
+              </a:spcAft>
+            </a:pPr>
+            <a:r>
+              <a:rPr sz="1400" b="0">
                 <a:solidFill>
                   <a:srgbClr val="000000"/>
                 </a:solidFill>
@@ -4650,17 +4650,17 @@
           <a:p>
             <a:pPr algn="l">
               <a:lnSpc>
-                <a:spcPts val="1430"/>
-              </a:lnSpc>
-              <a:spcBef>
-                <a:spcPts val="200"/>
-              </a:spcBef>
-              <a:spcAft>
-                <a:spcPts val="200"/>
-              </a:spcAft>
-            </a:pPr>
-            <a:r>
-              <a:rPr sz="1100" b="0">
+                <a:spcPts val="1820"/>
+              </a:lnSpc>
+              <a:spcBef>
+                <a:spcPts val="200"/>
+              </a:spcBef>
+              <a:spcAft>
+                <a:spcPts val="200"/>
+              </a:spcAft>
+            </a:pPr>
+            <a:r>
+              <a:rPr sz="1400" b="0">
                 <a:solidFill>
                   <a:srgbClr val="000000"/>
                 </a:solidFill>
@@ -4672,7 +4672,7 @@
           <a:p>
             <a:pPr algn="l">
               <a:lnSpc>
-                <a:spcPts val="1820"/>
+                <a:spcPts val="2080"/>
               </a:lnSpc>
               <a:spcBef>
                 <a:spcPts val="800"/>
@@ -4682,7 +4682,7 @@
               </a:spcAft>
             </a:pPr>
             <a:r>
-              <a:rPr sz="1400" b="1">
+              <a:rPr sz="1600" b="1">
                 <a:solidFill>
                   <a:srgbClr val="CC3333"/>
                 </a:solidFill>
@@ -4694,17 +4694,17 @@
           <a:p>
             <a:pPr algn="l">
               <a:lnSpc>
-                <a:spcPts val="1430"/>
-              </a:lnSpc>
-              <a:spcBef>
-                <a:spcPts val="200"/>
-              </a:spcBef>
-              <a:spcAft>
-                <a:spcPts val="200"/>
-              </a:spcAft>
-            </a:pPr>
-            <a:r>
-              <a:rPr sz="1100" b="0">
+                <a:spcPts val="1820"/>
+              </a:lnSpc>
+              <a:spcBef>
+                <a:spcPts val="200"/>
+              </a:spcBef>
+              <a:spcAft>
+                <a:spcPts val="200"/>
+              </a:spcAft>
+            </a:pPr>
+            <a:r>
+              <a:rPr sz="1400" b="0">
                 <a:solidFill>
                   <a:srgbClr val="000000"/>
                 </a:solidFill>
@@ -4716,7 +4716,7 @@
           <a:p>
             <a:pPr algn="l">
               <a:lnSpc>
-                <a:spcPts val="1820"/>
+                <a:spcPts val="2080"/>
               </a:lnSpc>
               <a:spcBef>
                 <a:spcPts val="800"/>
@@ -4726,7 +4726,7 @@
               </a:spcAft>
             </a:pPr>
             <a:r>
-              <a:rPr sz="1400" b="1">
+              <a:rPr sz="1600" b="1">
                 <a:solidFill>
                   <a:srgbClr val="008040"/>
                 </a:solidFill>
@@ -4738,17 +4738,17 @@
           <a:p>
             <a:pPr algn="l">
               <a:lnSpc>
-                <a:spcPts val="1430"/>
-              </a:lnSpc>
-              <a:spcBef>
-                <a:spcPts val="200"/>
-              </a:spcBef>
-              <a:spcAft>
-                <a:spcPts val="200"/>
-              </a:spcAft>
-            </a:pPr>
-            <a:r>
-              <a:rPr sz="1100" b="0">
+                <a:spcPts val="1820"/>
+              </a:lnSpc>
+              <a:spcBef>
+                <a:spcPts val="200"/>
+              </a:spcBef>
+              <a:spcAft>
+                <a:spcPts val="200"/>
+              </a:spcAft>
+            </a:pPr>
+            <a:r>
+              <a:rPr sz="1400" b="0">
                 <a:solidFill>
                   <a:srgbClr val="000000"/>
                 </a:solidFill>
@@ -4853,7 +4853,7 @@
           <a:p>
             <a:pPr algn="l">
               <a:lnSpc>
-                <a:spcPts val="1820"/>
+                <a:spcPts val="2080"/>
               </a:lnSpc>
               <a:spcBef>
                 <a:spcPts val="0"/>
@@ -4863,7 +4863,7 @@
               </a:spcAft>
             </a:pPr>
             <a:r>
-              <a:rPr sz="1400" b="1">
+              <a:rPr sz="1600" b="1">
                 <a:solidFill>
                   <a:srgbClr val="1B3A5C"/>
                 </a:solidFill>
@@ -4875,7 +4875,7 @@
           <a:p>
             <a:pPr algn="l">
               <a:lnSpc>
-                <a:spcPts val="1820"/>
+                <a:spcPts val="2080"/>
               </a:lnSpc>
               <a:spcBef>
                 <a:spcPts val="800"/>
@@ -4885,7 +4885,7 @@
               </a:spcAft>
             </a:pPr>
             <a:r>
-              <a:rPr sz="1400" b="1">
+              <a:rPr sz="1600" b="1">
                 <a:solidFill>
                   <a:srgbClr val="333333"/>
                 </a:solidFill>
@@ -4897,17 +4897,17 @@
           <a:p>
             <a:pPr algn="l">
               <a:lnSpc>
-                <a:spcPts val="1430"/>
-              </a:lnSpc>
-              <a:spcBef>
-                <a:spcPts val="200"/>
-              </a:spcBef>
-              <a:spcAft>
-                <a:spcPts val="200"/>
-              </a:spcAft>
-            </a:pPr>
-            <a:r>
-              <a:rPr sz="1100" b="0">
+                <a:spcPts val="1820"/>
+              </a:lnSpc>
+              <a:spcBef>
+                <a:spcPts val="200"/>
+              </a:spcBef>
+              <a:spcAft>
+                <a:spcPts val="200"/>
+              </a:spcAft>
+            </a:pPr>
+            <a:r>
+              <a:rPr sz="1400" b="0">
                 <a:solidFill>
                   <a:srgbClr val="000000"/>
                 </a:solidFill>
@@ -4919,7 +4919,7 @@
           <a:p>
             <a:pPr algn="l">
               <a:lnSpc>
-                <a:spcPts val="1820"/>
+                <a:spcPts val="2080"/>
               </a:lnSpc>
               <a:spcBef>
                 <a:spcPts val="800"/>
@@ -4929,7 +4929,7 @@
               </a:spcAft>
             </a:pPr>
             <a:r>
-              <a:rPr sz="1400" b="1">
+              <a:rPr sz="1600" b="1">
                 <a:solidFill>
                   <a:srgbClr val="1B5C9E"/>
                 </a:solidFill>
@@ -4941,17 +4941,17 @@
           <a:p>
             <a:pPr algn="l">
               <a:lnSpc>
-                <a:spcPts val="1430"/>
-              </a:lnSpc>
-              <a:spcBef>
-                <a:spcPts val="200"/>
-              </a:spcBef>
-              <a:spcAft>
-                <a:spcPts val="200"/>
-              </a:spcAft>
-            </a:pPr>
-            <a:r>
-              <a:rPr sz="1100" b="0">
+                <a:spcPts val="1820"/>
+              </a:lnSpc>
+              <a:spcBef>
+                <a:spcPts val="200"/>
+              </a:spcBef>
+              <a:spcAft>
+                <a:spcPts val="200"/>
+              </a:spcAft>
+            </a:pPr>
+            <a:r>
+              <a:rPr sz="1400" b="0">
                 <a:solidFill>
                   <a:srgbClr val="000000"/>
                 </a:solidFill>
@@ -4963,17 +4963,17 @@
           <a:p>
             <a:pPr algn="l">
               <a:lnSpc>
-                <a:spcPts val="1430"/>
-              </a:lnSpc>
-              <a:spcBef>
-                <a:spcPts val="200"/>
-              </a:spcBef>
-              <a:spcAft>
-                <a:spcPts val="200"/>
-              </a:spcAft>
-            </a:pPr>
-            <a:r>
-              <a:rPr sz="1100" b="0">
+                <a:spcPts val="1820"/>
+              </a:lnSpc>
+              <a:spcBef>
+                <a:spcPts val="200"/>
+              </a:spcBef>
+              <a:spcAft>
+                <a:spcPts val="200"/>
+              </a:spcAft>
+            </a:pPr>
+            <a:r>
+              <a:rPr sz="1400" b="0">
                 <a:solidFill>
                   <a:srgbClr val="000000"/>
                 </a:solidFill>
@@ -4985,17 +4985,17 @@
           <a:p>
             <a:pPr algn="l">
               <a:lnSpc>
-                <a:spcPts val="1430"/>
-              </a:lnSpc>
-              <a:spcBef>
-                <a:spcPts val="200"/>
-              </a:spcBef>
-              <a:spcAft>
-                <a:spcPts val="200"/>
-              </a:spcAft>
-            </a:pPr>
-            <a:r>
-              <a:rPr sz="1100" b="0">
+                <a:spcPts val="1820"/>
+              </a:lnSpc>
+              <a:spcBef>
+                <a:spcPts val="200"/>
+              </a:spcBef>
+              <a:spcAft>
+                <a:spcPts val="200"/>
+              </a:spcAft>
+            </a:pPr>
+            <a:r>
+              <a:rPr sz="1400" b="0">
                 <a:solidFill>
                   <a:srgbClr val="000000"/>
                 </a:solidFill>
@@ -5007,17 +5007,17 @@
           <a:p>
             <a:pPr algn="l">
               <a:lnSpc>
-                <a:spcPts val="1430"/>
-              </a:lnSpc>
-              <a:spcBef>
-                <a:spcPts val="200"/>
-              </a:spcBef>
-              <a:spcAft>
-                <a:spcPts val="200"/>
-              </a:spcAft>
-            </a:pPr>
-            <a:r>
-              <a:rPr sz="1100" b="0">
+                <a:spcPts val="1820"/>
+              </a:lnSpc>
+              <a:spcBef>
+                <a:spcPts val="200"/>
+              </a:spcBef>
+              <a:spcAft>
+                <a:spcPts val="200"/>
+              </a:spcAft>
+            </a:pPr>
+            <a:r>
+              <a:rPr sz="1400" b="0">
                 <a:solidFill>
                   <a:srgbClr val="000000"/>
                 </a:solidFill>
@@ -5029,7 +5029,7 @@
           <a:p>
             <a:pPr algn="l">
               <a:lnSpc>
-                <a:spcPts val="1820"/>
+                <a:spcPts val="2080"/>
               </a:lnSpc>
               <a:spcBef>
                 <a:spcPts val="800"/>
@@ -5039,7 +5039,7 @@
               </a:spcAft>
             </a:pPr>
             <a:r>
-              <a:rPr sz="1400" b="1">
+              <a:rPr sz="1600" b="1">
                 <a:solidFill>
                   <a:srgbClr val="CC3333"/>
                 </a:solidFill>
@@ -5051,17 +5051,17 @@
           <a:p>
             <a:pPr algn="l">
               <a:lnSpc>
-                <a:spcPts val="1430"/>
-              </a:lnSpc>
-              <a:spcBef>
-                <a:spcPts val="200"/>
-              </a:spcBef>
-              <a:spcAft>
-                <a:spcPts val="200"/>
-              </a:spcAft>
-            </a:pPr>
-            <a:r>
-              <a:rPr sz="1100" b="0">
+                <a:spcPts val="1820"/>
+              </a:lnSpc>
+              <a:spcBef>
+                <a:spcPts val="200"/>
+              </a:spcBef>
+              <a:spcAft>
+                <a:spcPts val="200"/>
+              </a:spcAft>
+            </a:pPr>
+            <a:r>
+              <a:rPr sz="1400" b="0">
                 <a:solidFill>
                   <a:srgbClr val="000000"/>
                 </a:solidFill>
@@ -5073,7 +5073,7 @@
           <a:p>
             <a:pPr algn="l">
               <a:lnSpc>
-                <a:spcPts val="1820"/>
+                <a:spcPts val="2080"/>
               </a:lnSpc>
               <a:spcBef>
                 <a:spcPts val="800"/>
@@ -5083,7 +5083,7 @@
               </a:spcAft>
             </a:pPr>
             <a:r>
-              <a:rPr sz="1400" b="1">
+              <a:rPr sz="1600" b="1">
                 <a:solidFill>
                   <a:srgbClr val="008040"/>
                 </a:solidFill>
@@ -5095,17 +5095,17 @@
           <a:p>
             <a:pPr algn="l">
               <a:lnSpc>
-                <a:spcPts val="1430"/>
-              </a:lnSpc>
-              <a:spcBef>
-                <a:spcPts val="200"/>
-              </a:spcBef>
-              <a:spcAft>
-                <a:spcPts val="200"/>
-              </a:spcAft>
-            </a:pPr>
-            <a:r>
-              <a:rPr sz="1100" b="0">
+                <a:spcPts val="1820"/>
+              </a:lnSpc>
+              <a:spcBef>
+                <a:spcPts val="200"/>
+              </a:spcBef>
+              <a:spcAft>
+                <a:spcPts val="200"/>
+              </a:spcAft>
+            </a:pPr>
+            <a:r>
+              <a:rPr sz="1400" b="0">
                 <a:solidFill>
                   <a:srgbClr val="000000"/>
                 </a:solidFill>
@@ -5210,7 +5210,7 @@
           <a:p>
             <a:pPr algn="l">
               <a:lnSpc>
-                <a:spcPts val="1820"/>
+                <a:spcPts val="2080"/>
               </a:lnSpc>
               <a:spcBef>
                 <a:spcPts val="0"/>
@@ -5220,7 +5220,7 @@
               </a:spcAft>
             </a:pPr>
             <a:r>
-              <a:rPr sz="1400" b="1">
+              <a:rPr sz="1600" b="1">
                 <a:solidFill>
                   <a:srgbClr val="1B3A5C"/>
                 </a:solidFill>
@@ -5232,7 +5232,7 @@
           <a:p>
             <a:pPr algn="l">
               <a:lnSpc>
-                <a:spcPts val="1820"/>
+                <a:spcPts val="2080"/>
               </a:lnSpc>
               <a:spcBef>
                 <a:spcPts val="800"/>
@@ -5242,7 +5242,7 @@
               </a:spcAft>
             </a:pPr>
             <a:r>
-              <a:rPr sz="1400" b="1">
+              <a:rPr sz="1600" b="1">
                 <a:solidFill>
                   <a:srgbClr val="333333"/>
                 </a:solidFill>
@@ -5254,17 +5254,17 @@
           <a:p>
             <a:pPr algn="l">
               <a:lnSpc>
-                <a:spcPts val="1430"/>
-              </a:lnSpc>
-              <a:spcBef>
-                <a:spcPts val="200"/>
-              </a:spcBef>
-              <a:spcAft>
-                <a:spcPts val="200"/>
-              </a:spcAft>
-            </a:pPr>
-            <a:r>
-              <a:rPr sz="1100" b="0">
+                <a:spcPts val="1820"/>
+              </a:lnSpc>
+              <a:spcBef>
+                <a:spcPts val="200"/>
+              </a:spcBef>
+              <a:spcAft>
+                <a:spcPts val="200"/>
+              </a:spcAft>
+            </a:pPr>
+            <a:r>
+              <a:rPr sz="1400" b="0">
                 <a:solidFill>
                   <a:srgbClr val="000000"/>
                 </a:solidFill>
@@ -5276,7 +5276,7 @@
           <a:p>
             <a:pPr algn="l">
               <a:lnSpc>
-                <a:spcPts val="1820"/>
+                <a:spcPts val="2080"/>
               </a:lnSpc>
               <a:spcBef>
                 <a:spcPts val="800"/>
@@ -5286,7 +5286,7 @@
               </a:spcAft>
             </a:pPr>
             <a:r>
-              <a:rPr sz="1400" b="1">
+              <a:rPr sz="1600" b="1">
                 <a:solidFill>
                   <a:srgbClr val="1B5C9E"/>
                 </a:solidFill>
@@ -5298,17 +5298,17 @@
           <a:p>
             <a:pPr algn="l">
               <a:lnSpc>
-                <a:spcPts val="1430"/>
-              </a:lnSpc>
-              <a:spcBef>
-                <a:spcPts val="200"/>
-              </a:spcBef>
-              <a:spcAft>
-                <a:spcPts val="200"/>
-              </a:spcAft>
-            </a:pPr>
-            <a:r>
-              <a:rPr sz="1100" b="0">
+                <a:spcPts val="1820"/>
+              </a:lnSpc>
+              <a:spcBef>
+                <a:spcPts val="200"/>
+              </a:spcBef>
+              <a:spcAft>
+                <a:spcPts val="200"/>
+              </a:spcAft>
+            </a:pPr>
+            <a:r>
+              <a:rPr sz="1400" b="0">
                 <a:solidFill>
                   <a:srgbClr val="000000"/>
                 </a:solidFill>
@@ -5320,17 +5320,17 @@
           <a:p>
             <a:pPr algn="l">
               <a:lnSpc>
-                <a:spcPts val="1430"/>
-              </a:lnSpc>
-              <a:spcBef>
-                <a:spcPts val="200"/>
-              </a:spcBef>
-              <a:spcAft>
-                <a:spcPts val="200"/>
-              </a:spcAft>
-            </a:pPr>
-            <a:r>
-              <a:rPr sz="1100" b="0">
+                <a:spcPts val="1820"/>
+              </a:lnSpc>
+              <a:spcBef>
+                <a:spcPts val="200"/>
+              </a:spcBef>
+              <a:spcAft>
+                <a:spcPts val="200"/>
+              </a:spcAft>
+            </a:pPr>
+            <a:r>
+              <a:rPr sz="1400" b="0">
                 <a:solidFill>
                   <a:srgbClr val="000000"/>
                 </a:solidFill>
@@ -5342,17 +5342,17 @@
           <a:p>
             <a:pPr algn="l">
               <a:lnSpc>
-                <a:spcPts val="1430"/>
-              </a:lnSpc>
-              <a:spcBef>
-                <a:spcPts val="200"/>
-              </a:spcBef>
-              <a:spcAft>
-                <a:spcPts val="200"/>
-              </a:spcAft>
-            </a:pPr>
-            <a:r>
-              <a:rPr sz="1100" b="0">
+                <a:spcPts val="1820"/>
+              </a:lnSpc>
+              <a:spcBef>
+                <a:spcPts val="200"/>
+              </a:spcBef>
+              <a:spcAft>
+                <a:spcPts val="200"/>
+              </a:spcAft>
+            </a:pPr>
+            <a:r>
+              <a:rPr sz="1400" b="0">
                 <a:solidFill>
                   <a:srgbClr val="000000"/>
                 </a:solidFill>
@@ -5364,7 +5364,7 @@
           <a:p>
             <a:pPr algn="l">
               <a:lnSpc>
-                <a:spcPts val="1820"/>
+                <a:spcPts val="2080"/>
               </a:lnSpc>
               <a:spcBef>
                 <a:spcPts val="800"/>
@@ -5374,7 +5374,7 @@
               </a:spcAft>
             </a:pPr>
             <a:r>
-              <a:rPr sz="1400" b="1">
+              <a:rPr sz="1600" b="1">
                 <a:solidFill>
                   <a:srgbClr val="CC3333"/>
                 </a:solidFill>
@@ -5386,17 +5386,17 @@
           <a:p>
             <a:pPr algn="l">
               <a:lnSpc>
-                <a:spcPts val="1430"/>
-              </a:lnSpc>
-              <a:spcBef>
-                <a:spcPts val="200"/>
-              </a:spcBef>
-              <a:spcAft>
-                <a:spcPts val="200"/>
-              </a:spcAft>
-            </a:pPr>
-            <a:r>
-              <a:rPr sz="1100" b="0">
+                <a:spcPts val="1820"/>
+              </a:lnSpc>
+              <a:spcBef>
+                <a:spcPts val="200"/>
+              </a:spcBef>
+              <a:spcAft>
+                <a:spcPts val="200"/>
+              </a:spcAft>
+            </a:pPr>
+            <a:r>
+              <a:rPr sz="1400" b="0">
                 <a:solidFill>
                   <a:srgbClr val="000000"/>
                 </a:solidFill>
@@ -5408,7 +5408,7 @@
           <a:p>
             <a:pPr algn="l">
               <a:lnSpc>
-                <a:spcPts val="1820"/>
+                <a:spcPts val="2080"/>
               </a:lnSpc>
               <a:spcBef>
                 <a:spcPts val="800"/>
@@ -5418,7 +5418,7 @@
               </a:spcAft>
             </a:pPr>
             <a:r>
-              <a:rPr sz="1400" b="1">
+              <a:rPr sz="1600" b="1">
                 <a:solidFill>
                   <a:srgbClr val="008040"/>
                 </a:solidFill>
@@ -5430,17 +5430,17 @@
           <a:p>
             <a:pPr algn="l">
               <a:lnSpc>
-                <a:spcPts val="1430"/>
-              </a:lnSpc>
-              <a:spcBef>
-                <a:spcPts val="200"/>
-              </a:spcBef>
-              <a:spcAft>
-                <a:spcPts val="200"/>
-              </a:spcAft>
-            </a:pPr>
-            <a:r>
-              <a:rPr sz="1100" b="0">
+                <a:spcPts val="1820"/>
+              </a:lnSpc>
+              <a:spcBef>
+                <a:spcPts val="200"/>
+              </a:spcBef>
+              <a:spcAft>
+                <a:spcPts val="200"/>
+              </a:spcAft>
+            </a:pPr>
+            <a:r>
+              <a:rPr sz="1400" b="0">
                 <a:solidFill>
                   <a:srgbClr val="000000"/>
                 </a:solidFill>
@@ -5452,17 +5452,17 @@
           <a:p>
             <a:pPr algn="l">
               <a:lnSpc>
-                <a:spcPts val="1430"/>
-              </a:lnSpc>
-              <a:spcBef>
-                <a:spcPts val="200"/>
-              </a:spcBef>
-              <a:spcAft>
-                <a:spcPts val="200"/>
-              </a:spcAft>
-            </a:pPr>
-            <a:r>
-              <a:rPr sz="1100" b="0">
+                <a:spcPts val="1820"/>
+              </a:lnSpc>
+              <a:spcBef>
+                <a:spcPts val="200"/>
+              </a:spcBef>
+              <a:spcAft>
+                <a:spcPts val="200"/>
+              </a:spcAft>
+            </a:pPr>
+            <a:r>
+              <a:rPr sz="1400" b="0">
                 <a:solidFill>
                   <a:srgbClr val="000000"/>
                 </a:solidFill>
@@ -5567,7 +5567,7 @@
           <a:p>
             <a:pPr algn="l">
               <a:lnSpc>
-                <a:spcPts val="1820"/>
+                <a:spcPts val="2080"/>
               </a:lnSpc>
               <a:spcBef>
                 <a:spcPts val="0"/>
@@ -5577,7 +5577,7 @@
               </a:spcAft>
             </a:pPr>
             <a:r>
-              <a:rPr sz="1400" b="1">
+              <a:rPr sz="1600" b="1">
                 <a:solidFill>
                   <a:srgbClr val="1B3A5C"/>
                 </a:solidFill>
@@ -5589,7 +5589,7 @@
           <a:p>
             <a:pPr algn="l">
               <a:lnSpc>
-                <a:spcPts val="1820"/>
+                <a:spcPts val="2080"/>
               </a:lnSpc>
               <a:spcBef>
                 <a:spcPts val="800"/>
@@ -5599,7 +5599,7 @@
               </a:spcAft>
             </a:pPr>
             <a:r>
-              <a:rPr sz="1400" b="1">
+              <a:rPr sz="1600" b="1">
                 <a:solidFill>
                   <a:srgbClr val="333333"/>
                 </a:solidFill>
@@ -5611,17 +5611,17 @@
           <a:p>
             <a:pPr algn="l">
               <a:lnSpc>
-                <a:spcPts val="1430"/>
-              </a:lnSpc>
-              <a:spcBef>
-                <a:spcPts val="200"/>
-              </a:spcBef>
-              <a:spcAft>
-                <a:spcPts val="200"/>
-              </a:spcAft>
-            </a:pPr>
-            <a:r>
-              <a:rPr sz="1100" b="0">
+                <a:spcPts val="1820"/>
+              </a:lnSpc>
+              <a:spcBef>
+                <a:spcPts val="200"/>
+              </a:spcBef>
+              <a:spcAft>
+                <a:spcPts val="200"/>
+              </a:spcAft>
+            </a:pPr>
+            <a:r>
+              <a:rPr sz="1400" b="0">
                 <a:solidFill>
                   <a:srgbClr val="000000"/>
                 </a:solidFill>
@@ -5633,7 +5633,7 @@
           <a:p>
             <a:pPr algn="l">
               <a:lnSpc>
-                <a:spcPts val="1820"/>
+                <a:spcPts val="2080"/>
               </a:lnSpc>
               <a:spcBef>
                 <a:spcPts val="800"/>
@@ -5643,7 +5643,7 @@
               </a:spcAft>
             </a:pPr>
             <a:r>
-              <a:rPr sz="1400" b="1">
+              <a:rPr sz="1600" b="1">
                 <a:solidFill>
                   <a:srgbClr val="1B5C9E"/>
                 </a:solidFill>
@@ -5655,17 +5655,17 @@
           <a:p>
             <a:pPr algn="l">
               <a:lnSpc>
-                <a:spcPts val="1430"/>
-              </a:lnSpc>
-              <a:spcBef>
-                <a:spcPts val="200"/>
-              </a:spcBef>
-              <a:spcAft>
-                <a:spcPts val="200"/>
-              </a:spcAft>
-            </a:pPr>
-            <a:r>
-              <a:rPr sz="1100" b="0">
+                <a:spcPts val="1820"/>
+              </a:lnSpc>
+              <a:spcBef>
+                <a:spcPts val="200"/>
+              </a:spcBef>
+              <a:spcAft>
+                <a:spcPts val="200"/>
+              </a:spcAft>
+            </a:pPr>
+            <a:r>
+              <a:rPr sz="1400" b="0">
                 <a:solidFill>
                   <a:srgbClr val="000000"/>
                 </a:solidFill>
@@ -5677,17 +5677,17 @@
           <a:p>
             <a:pPr algn="l">
               <a:lnSpc>
-                <a:spcPts val="1430"/>
-              </a:lnSpc>
-              <a:spcBef>
-                <a:spcPts val="200"/>
-              </a:spcBef>
-              <a:spcAft>
-                <a:spcPts val="200"/>
-              </a:spcAft>
-            </a:pPr>
-            <a:r>
-              <a:rPr sz="1100" b="0">
+                <a:spcPts val="1820"/>
+              </a:lnSpc>
+              <a:spcBef>
+                <a:spcPts val="200"/>
+              </a:spcBef>
+              <a:spcAft>
+                <a:spcPts val="200"/>
+              </a:spcAft>
+            </a:pPr>
+            <a:r>
+              <a:rPr sz="1400" b="0">
                 <a:solidFill>
                   <a:srgbClr val="000000"/>
                 </a:solidFill>
@@ -5699,7 +5699,7 @@
           <a:p>
             <a:pPr algn="l">
               <a:lnSpc>
-                <a:spcPts val="1820"/>
+                <a:spcPts val="2080"/>
               </a:lnSpc>
               <a:spcBef>
                 <a:spcPts val="800"/>
@@ -5709,7 +5709,7 @@
               </a:spcAft>
             </a:pPr>
             <a:r>
-              <a:rPr sz="1400" b="1">
+              <a:rPr sz="1600" b="1">
                 <a:solidFill>
                   <a:srgbClr val="CC3333"/>
                 </a:solidFill>
@@ -5721,17 +5721,17 @@
           <a:p>
             <a:pPr algn="l">
               <a:lnSpc>
-                <a:spcPts val="1430"/>
-              </a:lnSpc>
-              <a:spcBef>
-                <a:spcPts val="200"/>
-              </a:spcBef>
-              <a:spcAft>
-                <a:spcPts val="200"/>
-              </a:spcAft>
-            </a:pPr>
-            <a:r>
-              <a:rPr sz="1100" b="0">
+                <a:spcPts val="1820"/>
+              </a:lnSpc>
+              <a:spcBef>
+                <a:spcPts val="200"/>
+              </a:spcBef>
+              <a:spcAft>
+                <a:spcPts val="200"/>
+              </a:spcAft>
+            </a:pPr>
+            <a:r>
+              <a:rPr sz="1400" b="0">
                 <a:solidFill>
                   <a:srgbClr val="000000"/>
                 </a:solidFill>
@@ -5743,7 +5743,7 @@
           <a:p>
             <a:pPr algn="l">
               <a:lnSpc>
-                <a:spcPts val="1820"/>
+                <a:spcPts val="2080"/>
               </a:lnSpc>
               <a:spcBef>
                 <a:spcPts val="800"/>
@@ -5753,7 +5753,7 @@
               </a:spcAft>
             </a:pPr>
             <a:r>
-              <a:rPr sz="1400" b="1">
+              <a:rPr sz="1600" b="1">
                 <a:solidFill>
                   <a:srgbClr val="008040"/>
                 </a:solidFill>
@@ -5765,17 +5765,17 @@
           <a:p>
             <a:pPr algn="l">
               <a:lnSpc>
-                <a:spcPts val="1430"/>
-              </a:lnSpc>
-              <a:spcBef>
-                <a:spcPts val="200"/>
-              </a:spcBef>
-              <a:spcAft>
-                <a:spcPts val="200"/>
-              </a:spcAft>
-            </a:pPr>
-            <a:r>
-              <a:rPr sz="1100" b="0">
+                <a:spcPts val="1820"/>
+              </a:lnSpc>
+              <a:spcBef>
+                <a:spcPts val="200"/>
+              </a:spcBef>
+              <a:spcAft>
+                <a:spcPts val="200"/>
+              </a:spcAft>
+            </a:pPr>
+            <a:r>
+              <a:rPr sz="1400" b="0">
                 <a:solidFill>
                   <a:srgbClr val="000000"/>
                 </a:solidFill>
@@ -5880,7 +5880,7 @@
           <a:p>
             <a:pPr algn="l">
               <a:lnSpc>
-                <a:spcPts val="1820"/>
+                <a:spcPts val="2080"/>
               </a:lnSpc>
               <a:spcBef>
                 <a:spcPts val="0"/>
@@ -5890,7 +5890,7 @@
               </a:spcAft>
             </a:pPr>
             <a:r>
-              <a:rPr sz="1400" b="1">
+              <a:rPr sz="1600" b="1">
                 <a:solidFill>
                   <a:srgbClr val="1B3A5C"/>
                 </a:solidFill>
@@ -5902,7 +5902,7 @@
           <a:p>
             <a:pPr algn="l">
               <a:lnSpc>
-                <a:spcPts val="1820"/>
+                <a:spcPts val="2080"/>
               </a:lnSpc>
               <a:spcBef>
                 <a:spcPts val="800"/>
@@ -5912,7 +5912,7 @@
               </a:spcAft>
             </a:pPr>
             <a:r>
-              <a:rPr sz="1400" b="1">
+              <a:rPr sz="1600" b="1">
                 <a:solidFill>
                   <a:srgbClr val="333333"/>
                 </a:solidFill>
@@ -5924,17 +5924,17 @@
           <a:p>
             <a:pPr algn="l">
               <a:lnSpc>
-                <a:spcPts val="1430"/>
-              </a:lnSpc>
-              <a:spcBef>
-                <a:spcPts val="200"/>
-              </a:spcBef>
-              <a:spcAft>
-                <a:spcPts val="200"/>
-              </a:spcAft>
-            </a:pPr>
-            <a:r>
-              <a:rPr sz="1100" b="0">
+                <a:spcPts val="1820"/>
+              </a:lnSpc>
+              <a:spcBef>
+                <a:spcPts val="200"/>
+              </a:spcBef>
+              <a:spcAft>
+                <a:spcPts val="200"/>
+              </a:spcAft>
+            </a:pPr>
+            <a:r>
+              <a:rPr sz="1400" b="0">
                 <a:solidFill>
                   <a:srgbClr val="000000"/>
                 </a:solidFill>
@@ -5946,7 +5946,7 @@
           <a:p>
             <a:pPr algn="l">
               <a:lnSpc>
-                <a:spcPts val="1820"/>
+                <a:spcPts val="2080"/>
               </a:lnSpc>
               <a:spcBef>
                 <a:spcPts val="800"/>
@@ -5956,7 +5956,7 @@
               </a:spcAft>
             </a:pPr>
             <a:r>
-              <a:rPr sz="1400" b="1">
+              <a:rPr sz="1600" b="1">
                 <a:solidFill>
                   <a:srgbClr val="1B5C9E"/>
                 </a:solidFill>
@@ -5968,17 +5968,17 @@
           <a:p>
             <a:pPr algn="l">
               <a:lnSpc>
-                <a:spcPts val="1430"/>
-              </a:lnSpc>
-              <a:spcBef>
-                <a:spcPts val="200"/>
-              </a:spcBef>
-              <a:spcAft>
-                <a:spcPts val="200"/>
-              </a:spcAft>
-            </a:pPr>
-            <a:r>
-              <a:rPr sz="1100" b="0">
+                <a:spcPts val="1820"/>
+              </a:lnSpc>
+              <a:spcBef>
+                <a:spcPts val="200"/>
+              </a:spcBef>
+              <a:spcAft>
+                <a:spcPts val="200"/>
+              </a:spcAft>
+            </a:pPr>
+            <a:r>
+              <a:rPr sz="1400" b="0">
                 <a:solidFill>
                   <a:srgbClr val="000000"/>
                 </a:solidFill>
@@ -5990,17 +5990,17 @@
           <a:p>
             <a:pPr algn="l">
               <a:lnSpc>
-                <a:spcPts val="1430"/>
-              </a:lnSpc>
-              <a:spcBef>
-                <a:spcPts val="200"/>
-              </a:spcBef>
-              <a:spcAft>
-                <a:spcPts val="200"/>
-              </a:spcAft>
-            </a:pPr>
-            <a:r>
-              <a:rPr sz="1100" b="0">
+                <a:spcPts val="1820"/>
+              </a:lnSpc>
+              <a:spcBef>
+                <a:spcPts val="200"/>
+              </a:spcBef>
+              <a:spcAft>
+                <a:spcPts val="200"/>
+              </a:spcAft>
+            </a:pPr>
+            <a:r>
+              <a:rPr sz="1400" b="0">
                 <a:solidFill>
                   <a:srgbClr val="000000"/>
                 </a:solidFill>
@@ -6012,17 +6012,17 @@
           <a:p>
             <a:pPr algn="l">
               <a:lnSpc>
-                <a:spcPts val="1430"/>
-              </a:lnSpc>
-              <a:spcBef>
-                <a:spcPts val="200"/>
-              </a:spcBef>
-              <a:spcAft>
-                <a:spcPts val="200"/>
-              </a:spcAft>
-            </a:pPr>
-            <a:r>
-              <a:rPr sz="1100" b="0">
+                <a:spcPts val="1820"/>
+              </a:lnSpc>
+              <a:spcBef>
+                <a:spcPts val="200"/>
+              </a:spcBef>
+              <a:spcAft>
+                <a:spcPts val="200"/>
+              </a:spcAft>
+            </a:pPr>
+            <a:r>
+              <a:rPr sz="1400" b="0">
                 <a:solidFill>
                   <a:srgbClr val="000000"/>
                 </a:solidFill>
@@ -6034,7 +6034,7 @@
           <a:p>
             <a:pPr algn="l">
               <a:lnSpc>
-                <a:spcPts val="1820"/>
+                <a:spcPts val="2080"/>
               </a:lnSpc>
               <a:spcBef>
                 <a:spcPts val="800"/>
@@ -6044,7 +6044,7 @@
               </a:spcAft>
             </a:pPr>
             <a:r>
-              <a:rPr sz="1400" b="1">
+              <a:rPr sz="1600" b="1">
                 <a:solidFill>
                   <a:srgbClr val="CC3333"/>
                 </a:solidFill>
@@ -6056,17 +6056,17 @@
           <a:p>
             <a:pPr algn="l">
               <a:lnSpc>
-                <a:spcPts val="1430"/>
-              </a:lnSpc>
-              <a:spcBef>
-                <a:spcPts val="200"/>
-              </a:spcBef>
-              <a:spcAft>
-                <a:spcPts val="200"/>
-              </a:spcAft>
-            </a:pPr>
-            <a:r>
-              <a:rPr sz="1100" b="0">
+                <a:spcPts val="1820"/>
+              </a:lnSpc>
+              <a:spcBef>
+                <a:spcPts val="200"/>
+              </a:spcBef>
+              <a:spcAft>
+                <a:spcPts val="200"/>
+              </a:spcAft>
+            </a:pPr>
+            <a:r>
+              <a:rPr sz="1400" b="0">
                 <a:solidFill>
                   <a:srgbClr val="000000"/>
                 </a:solidFill>
@@ -6078,7 +6078,7 @@
           <a:p>
             <a:pPr algn="l">
               <a:lnSpc>
-                <a:spcPts val="1820"/>
+                <a:spcPts val="2080"/>
               </a:lnSpc>
               <a:spcBef>
                 <a:spcPts val="800"/>
@@ -6088,7 +6088,7 @@
               </a:spcAft>
             </a:pPr>
             <a:r>
-              <a:rPr sz="1400" b="1">
+              <a:rPr sz="1600" b="1">
                 <a:solidFill>
                   <a:srgbClr val="008040"/>
                 </a:solidFill>
@@ -6100,17 +6100,17 @@
           <a:p>
             <a:pPr algn="l">
               <a:lnSpc>
-                <a:spcPts val="1430"/>
-              </a:lnSpc>
-              <a:spcBef>
-                <a:spcPts val="200"/>
-              </a:spcBef>
-              <a:spcAft>
-                <a:spcPts val="200"/>
-              </a:spcAft>
-            </a:pPr>
-            <a:r>
-              <a:rPr sz="1100" b="0">
+                <a:spcPts val="1820"/>
+              </a:lnSpc>
+              <a:spcBef>
+                <a:spcPts val="200"/>
+              </a:spcBef>
+              <a:spcAft>
+                <a:spcPts val="200"/>
+              </a:spcAft>
+            </a:pPr>
+            <a:r>
+              <a:rPr sz="1400" b="0">
                 <a:solidFill>
                   <a:srgbClr val="000000"/>
                 </a:solidFill>
@@ -6122,17 +6122,17 @@
           <a:p>
             <a:pPr algn="l">
               <a:lnSpc>
-                <a:spcPts val="1430"/>
-              </a:lnSpc>
-              <a:spcBef>
-                <a:spcPts val="200"/>
-              </a:spcBef>
-              <a:spcAft>
-                <a:spcPts val="200"/>
-              </a:spcAft>
-            </a:pPr>
-            <a:r>
-              <a:rPr sz="1100" b="0">
+                <a:spcPts val="1820"/>
+              </a:lnSpc>
+              <a:spcBef>
+                <a:spcPts val="200"/>
+              </a:spcBef>
+              <a:spcAft>
+                <a:spcPts val="200"/>
+              </a:spcAft>
+            </a:pPr>
+            <a:r>
+              <a:rPr sz="1400" b="0">
                 <a:solidFill>
                   <a:srgbClr val="000000"/>
                 </a:solidFill>
@@ -6237,7 +6237,7 @@
           <a:p>
             <a:pPr algn="l">
               <a:lnSpc>
-                <a:spcPts val="1820"/>
+                <a:spcPts val="2080"/>
               </a:lnSpc>
               <a:spcBef>
                 <a:spcPts val="0"/>
@@ -6247,7 +6247,7 @@
               </a:spcAft>
             </a:pPr>
             <a:r>
-              <a:rPr sz="1400" b="1">
+              <a:rPr sz="1600" b="1">
                 <a:solidFill>
                   <a:srgbClr val="1B3A5C"/>
                 </a:solidFill>
@@ -6259,7 +6259,7 @@
           <a:p>
             <a:pPr algn="l">
               <a:lnSpc>
-                <a:spcPts val="1820"/>
+                <a:spcPts val="2080"/>
               </a:lnSpc>
               <a:spcBef>
                 <a:spcPts val="800"/>
@@ -6269,7 +6269,7 @@
               </a:spcAft>
             </a:pPr>
             <a:r>
-              <a:rPr sz="1400" b="1">
+              <a:rPr sz="1600" b="1">
                 <a:solidFill>
                   <a:srgbClr val="333333"/>
                 </a:solidFill>
@@ -6281,17 +6281,17 @@
           <a:p>
             <a:pPr algn="l">
               <a:lnSpc>
-                <a:spcPts val="1430"/>
-              </a:lnSpc>
-              <a:spcBef>
-                <a:spcPts val="200"/>
-              </a:spcBef>
-              <a:spcAft>
-                <a:spcPts val="200"/>
-              </a:spcAft>
-            </a:pPr>
-            <a:r>
-              <a:rPr sz="1100" b="0">
+                <a:spcPts val="1820"/>
+              </a:lnSpc>
+              <a:spcBef>
+                <a:spcPts val="200"/>
+              </a:spcBef>
+              <a:spcAft>
+                <a:spcPts val="200"/>
+              </a:spcAft>
+            </a:pPr>
+            <a:r>
+              <a:rPr sz="1400" b="0">
                 <a:solidFill>
                   <a:srgbClr val="000000"/>
                 </a:solidFill>
@@ -6303,7 +6303,7 @@
           <a:p>
             <a:pPr algn="l">
               <a:lnSpc>
-                <a:spcPts val="1820"/>
+                <a:spcPts val="2080"/>
               </a:lnSpc>
               <a:spcBef>
                 <a:spcPts val="800"/>
@@ -6313,7 +6313,7 @@
               </a:spcAft>
             </a:pPr>
             <a:r>
-              <a:rPr sz="1400" b="1">
+              <a:rPr sz="1600" b="1">
                 <a:solidFill>
                   <a:srgbClr val="1B5C9E"/>
                 </a:solidFill>
@@ -6325,17 +6325,17 @@
           <a:p>
             <a:pPr algn="l">
               <a:lnSpc>
-                <a:spcPts val="1430"/>
-              </a:lnSpc>
-              <a:spcBef>
-                <a:spcPts val="200"/>
-              </a:spcBef>
-              <a:spcAft>
-                <a:spcPts val="200"/>
-              </a:spcAft>
-            </a:pPr>
-            <a:r>
-              <a:rPr sz="1100" b="0">
+                <a:spcPts val="1820"/>
+              </a:lnSpc>
+              <a:spcBef>
+                <a:spcPts val="200"/>
+              </a:spcBef>
+              <a:spcAft>
+                <a:spcPts val="200"/>
+              </a:spcAft>
+            </a:pPr>
+            <a:r>
+              <a:rPr sz="1400" b="0">
                 <a:solidFill>
                   <a:srgbClr val="000000"/>
                 </a:solidFill>
@@ -6347,17 +6347,17 @@
           <a:p>
             <a:pPr algn="l">
               <a:lnSpc>
-                <a:spcPts val="1430"/>
-              </a:lnSpc>
-              <a:spcBef>
-                <a:spcPts val="200"/>
-              </a:spcBef>
-              <a:spcAft>
-                <a:spcPts val="200"/>
-              </a:spcAft>
-            </a:pPr>
-            <a:r>
-              <a:rPr sz="1100" b="0">
+                <a:spcPts val="1820"/>
+              </a:lnSpc>
+              <a:spcBef>
+                <a:spcPts val="200"/>
+              </a:spcBef>
+              <a:spcAft>
+                <a:spcPts val="200"/>
+              </a:spcAft>
+            </a:pPr>
+            <a:r>
+              <a:rPr sz="1400" b="0">
                 <a:solidFill>
                   <a:srgbClr val="000000"/>
                 </a:solidFill>
@@ -6369,17 +6369,17 @@
           <a:p>
             <a:pPr algn="l">
               <a:lnSpc>
-                <a:spcPts val="1430"/>
-              </a:lnSpc>
-              <a:spcBef>
-                <a:spcPts val="200"/>
-              </a:spcBef>
-              <a:spcAft>
-                <a:spcPts val="200"/>
-              </a:spcAft>
-            </a:pPr>
-            <a:r>
-              <a:rPr sz="1100" b="0">
+                <a:spcPts val="1820"/>
+              </a:lnSpc>
+              <a:spcBef>
+                <a:spcPts val="200"/>
+              </a:spcBef>
+              <a:spcAft>
+                <a:spcPts val="200"/>
+              </a:spcAft>
+            </a:pPr>
+            <a:r>
+              <a:rPr sz="1400" b="0">
                 <a:solidFill>
                   <a:srgbClr val="000000"/>
                 </a:solidFill>
@@ -6391,17 +6391,17 @@
           <a:p>
             <a:pPr algn="l">
               <a:lnSpc>
-                <a:spcPts val="1430"/>
-              </a:lnSpc>
-              <a:spcBef>
-                <a:spcPts val="200"/>
-              </a:spcBef>
-              <a:spcAft>
-                <a:spcPts val="200"/>
-              </a:spcAft>
-            </a:pPr>
-            <a:r>
-              <a:rPr sz="1100" b="0">
+                <a:spcPts val="1820"/>
+              </a:lnSpc>
+              <a:spcBef>
+                <a:spcPts val="200"/>
+              </a:spcBef>
+              <a:spcAft>
+                <a:spcPts val="200"/>
+              </a:spcAft>
+            </a:pPr>
+            <a:r>
+              <a:rPr sz="1400" b="0">
                 <a:solidFill>
                   <a:srgbClr val="000000"/>
                 </a:solidFill>
@@ -6413,7 +6413,7 @@
           <a:p>
             <a:pPr algn="l">
               <a:lnSpc>
-                <a:spcPts val="1820"/>
+                <a:spcPts val="2080"/>
               </a:lnSpc>
               <a:spcBef>
                 <a:spcPts val="800"/>
@@ -6423,7 +6423,7 @@
               </a:spcAft>
             </a:pPr>
             <a:r>
-              <a:rPr sz="1400" b="1">
+              <a:rPr sz="1600" b="1">
                 <a:solidFill>
                   <a:srgbClr val="CC3333"/>
                 </a:solidFill>
@@ -6435,17 +6435,17 @@
           <a:p>
             <a:pPr algn="l">
               <a:lnSpc>
-                <a:spcPts val="1430"/>
-              </a:lnSpc>
-              <a:spcBef>
-                <a:spcPts val="200"/>
-              </a:spcBef>
-              <a:spcAft>
-                <a:spcPts val="200"/>
-              </a:spcAft>
-            </a:pPr>
-            <a:r>
-              <a:rPr sz="1100" b="0">
+                <a:spcPts val="1820"/>
+              </a:lnSpc>
+              <a:spcBef>
+                <a:spcPts val="200"/>
+              </a:spcBef>
+              <a:spcAft>
+                <a:spcPts val="200"/>
+              </a:spcAft>
+            </a:pPr>
+            <a:r>
+              <a:rPr sz="1400" b="0">
                 <a:solidFill>
                   <a:srgbClr val="000000"/>
                 </a:solidFill>
@@ -6457,7 +6457,7 @@
           <a:p>
             <a:pPr algn="l">
               <a:lnSpc>
-                <a:spcPts val="1820"/>
+                <a:spcPts val="2080"/>
               </a:lnSpc>
               <a:spcBef>
                 <a:spcPts val="800"/>
@@ -6467,7 +6467,7 @@
               </a:spcAft>
             </a:pPr>
             <a:r>
-              <a:rPr sz="1400" b="1">
+              <a:rPr sz="1600" b="1">
                 <a:solidFill>
                   <a:srgbClr val="008040"/>
                 </a:solidFill>
@@ -6479,17 +6479,17 @@
           <a:p>
             <a:pPr algn="l">
               <a:lnSpc>
-                <a:spcPts val="1430"/>
-              </a:lnSpc>
-              <a:spcBef>
-                <a:spcPts val="200"/>
-              </a:spcBef>
-              <a:spcAft>
-                <a:spcPts val="200"/>
-              </a:spcAft>
-            </a:pPr>
-            <a:r>
-              <a:rPr sz="1100" b="0">
+                <a:spcPts val="1820"/>
+              </a:lnSpc>
+              <a:spcBef>
+                <a:spcPts val="200"/>
+              </a:spcBef>
+              <a:spcAft>
+                <a:spcPts val="200"/>
+              </a:spcAft>
+            </a:pPr>
+            <a:r>
+              <a:rPr sz="1400" b="0">
                 <a:solidFill>
                   <a:srgbClr val="000000"/>
                 </a:solidFill>
@@ -6594,7 +6594,7 @@
           <a:p>
             <a:pPr algn="l">
               <a:lnSpc>
-                <a:spcPts val="1820"/>
+                <a:spcPts val="2080"/>
               </a:lnSpc>
               <a:spcBef>
                 <a:spcPts val="0"/>
@@ -6604,7 +6604,7 @@
               </a:spcAft>
             </a:pPr>
             <a:r>
-              <a:rPr sz="1400" b="1">
+              <a:rPr sz="1600" b="1">
                 <a:solidFill>
                   <a:srgbClr val="1B3A5C"/>
                 </a:solidFill>
@@ -6616,7 +6616,7 @@
           <a:p>
             <a:pPr algn="l">
               <a:lnSpc>
-                <a:spcPts val="1820"/>
+                <a:spcPts val="2080"/>
               </a:lnSpc>
               <a:spcBef>
                 <a:spcPts val="800"/>
@@ -6626,7 +6626,7 @@
               </a:spcAft>
             </a:pPr>
             <a:r>
-              <a:rPr sz="1400" b="1">
+              <a:rPr sz="1600" b="1">
                 <a:solidFill>
                   <a:srgbClr val="333333"/>
                 </a:solidFill>
@@ -6638,17 +6638,17 @@
           <a:p>
             <a:pPr algn="l">
               <a:lnSpc>
-                <a:spcPts val="1430"/>
-              </a:lnSpc>
-              <a:spcBef>
-                <a:spcPts val="200"/>
-              </a:spcBef>
-              <a:spcAft>
-                <a:spcPts val="200"/>
-              </a:spcAft>
-            </a:pPr>
-            <a:r>
-              <a:rPr sz="1100" b="0">
+                <a:spcPts val="1820"/>
+              </a:lnSpc>
+              <a:spcBef>
+                <a:spcPts val="200"/>
+              </a:spcBef>
+              <a:spcAft>
+                <a:spcPts val="200"/>
+              </a:spcAft>
+            </a:pPr>
+            <a:r>
+              <a:rPr sz="1400" b="0">
                 <a:solidFill>
                   <a:srgbClr val="000000"/>
                 </a:solidFill>
@@ -6660,7 +6660,7 @@
           <a:p>
             <a:pPr algn="l">
               <a:lnSpc>
-                <a:spcPts val="1820"/>
+                <a:spcPts val="2080"/>
               </a:lnSpc>
               <a:spcBef>
                 <a:spcPts val="800"/>
@@ -6670,7 +6670,7 @@
               </a:spcAft>
             </a:pPr>
             <a:r>
-              <a:rPr sz="1400" b="1">
+              <a:rPr sz="1600" b="1">
                 <a:solidFill>
                   <a:srgbClr val="1B5C9E"/>
                 </a:solidFill>
@@ -6682,17 +6682,17 @@
           <a:p>
             <a:pPr algn="l">
               <a:lnSpc>
-                <a:spcPts val="1430"/>
-              </a:lnSpc>
-              <a:spcBef>
-                <a:spcPts val="200"/>
-              </a:spcBef>
-              <a:spcAft>
-                <a:spcPts val="200"/>
-              </a:spcAft>
-            </a:pPr>
-            <a:r>
-              <a:rPr sz="1100" b="0">
+                <a:spcPts val="1820"/>
+              </a:lnSpc>
+              <a:spcBef>
+                <a:spcPts val="200"/>
+              </a:spcBef>
+              <a:spcAft>
+                <a:spcPts val="200"/>
+              </a:spcAft>
+            </a:pPr>
+            <a:r>
+              <a:rPr sz="1400" b="0">
                 <a:solidFill>
                   <a:srgbClr val="000000"/>
                 </a:solidFill>
@@ -6704,17 +6704,17 @@
           <a:p>
             <a:pPr algn="l">
               <a:lnSpc>
-                <a:spcPts val="1430"/>
-              </a:lnSpc>
-              <a:spcBef>
-                <a:spcPts val="200"/>
-              </a:spcBef>
-              <a:spcAft>
-                <a:spcPts val="200"/>
-              </a:spcAft>
-            </a:pPr>
-            <a:r>
-              <a:rPr sz="1100" b="0">
+                <a:spcPts val="1820"/>
+              </a:lnSpc>
+              <a:spcBef>
+                <a:spcPts val="200"/>
+              </a:spcBef>
+              <a:spcAft>
+                <a:spcPts val="200"/>
+              </a:spcAft>
+            </a:pPr>
+            <a:r>
+              <a:rPr sz="1400" b="0">
                 <a:solidFill>
                   <a:srgbClr val="000000"/>
                 </a:solidFill>
@@ -6726,17 +6726,17 @@
           <a:p>
             <a:pPr algn="l">
               <a:lnSpc>
-                <a:spcPts val="1430"/>
-              </a:lnSpc>
-              <a:spcBef>
-                <a:spcPts val="200"/>
-              </a:spcBef>
-              <a:spcAft>
-                <a:spcPts val="200"/>
-              </a:spcAft>
-            </a:pPr>
-            <a:r>
-              <a:rPr sz="1100" b="0">
+                <a:spcPts val="1820"/>
+              </a:lnSpc>
+              <a:spcBef>
+                <a:spcPts val="200"/>
+              </a:spcBef>
+              <a:spcAft>
+                <a:spcPts val="200"/>
+              </a:spcAft>
+            </a:pPr>
+            <a:r>
+              <a:rPr sz="1400" b="0">
                 <a:solidFill>
                   <a:srgbClr val="000000"/>
                 </a:solidFill>
@@ -6748,17 +6748,17 @@
           <a:p>
             <a:pPr algn="l">
               <a:lnSpc>
-                <a:spcPts val="1430"/>
-              </a:lnSpc>
-              <a:spcBef>
-                <a:spcPts val="200"/>
-              </a:spcBef>
-              <a:spcAft>
-                <a:spcPts val="200"/>
-              </a:spcAft>
-            </a:pPr>
-            <a:r>
-              <a:rPr sz="1100" b="0">
+                <a:spcPts val="1820"/>
+              </a:lnSpc>
+              <a:spcBef>
+                <a:spcPts val="200"/>
+              </a:spcBef>
+              <a:spcAft>
+                <a:spcPts val="200"/>
+              </a:spcAft>
+            </a:pPr>
+            <a:r>
+              <a:rPr sz="1400" b="0">
                 <a:solidFill>
                   <a:srgbClr val="000000"/>
                 </a:solidFill>
@@ -6770,7 +6770,7 @@
           <a:p>
             <a:pPr algn="l">
               <a:lnSpc>
-                <a:spcPts val="1820"/>
+                <a:spcPts val="2080"/>
               </a:lnSpc>
               <a:spcBef>
                 <a:spcPts val="800"/>
@@ -6780,7 +6780,7 @@
               </a:spcAft>
             </a:pPr>
             <a:r>
-              <a:rPr sz="1400" b="1">
+              <a:rPr sz="1600" b="1">
                 <a:solidFill>
                   <a:srgbClr val="CC3333"/>
                 </a:solidFill>
@@ -6792,17 +6792,17 @@
           <a:p>
             <a:pPr algn="l">
               <a:lnSpc>
-                <a:spcPts val="1430"/>
-              </a:lnSpc>
-              <a:spcBef>
-                <a:spcPts val="200"/>
-              </a:spcBef>
-              <a:spcAft>
-                <a:spcPts val="200"/>
-              </a:spcAft>
-            </a:pPr>
-            <a:r>
-              <a:rPr sz="1100" b="0">
+                <a:spcPts val="1820"/>
+              </a:lnSpc>
+              <a:spcBef>
+                <a:spcPts val="200"/>
+              </a:spcBef>
+              <a:spcAft>
+                <a:spcPts val="200"/>
+              </a:spcAft>
+            </a:pPr>
+            <a:r>
+              <a:rPr sz="1400" b="0">
                 <a:solidFill>
                   <a:srgbClr val="000000"/>
                 </a:solidFill>
@@ -6814,7 +6814,7 @@
           <a:p>
             <a:pPr algn="l">
               <a:lnSpc>
-                <a:spcPts val="1820"/>
+                <a:spcPts val="2080"/>
               </a:lnSpc>
               <a:spcBef>
                 <a:spcPts val="800"/>
@@ -6824,7 +6824,7 @@
               </a:spcAft>
             </a:pPr>
             <a:r>
-              <a:rPr sz="1400" b="1">
+              <a:rPr sz="1600" b="1">
                 <a:solidFill>
                   <a:srgbClr val="008040"/>
                 </a:solidFill>
@@ -6836,17 +6836,17 @@
           <a:p>
             <a:pPr algn="l">
               <a:lnSpc>
-                <a:spcPts val="1430"/>
-              </a:lnSpc>
-              <a:spcBef>
-                <a:spcPts val="200"/>
-              </a:spcBef>
-              <a:spcAft>
-                <a:spcPts val="200"/>
-              </a:spcAft>
-            </a:pPr>
-            <a:r>
-              <a:rPr sz="1100" b="0">
+                <a:spcPts val="1820"/>
+              </a:lnSpc>
+              <a:spcBef>
+                <a:spcPts val="200"/>
+              </a:spcBef>
+              <a:spcAft>
+                <a:spcPts val="200"/>
+              </a:spcAft>
+            </a:pPr>
+            <a:r>
+              <a:rPr sz="1400" b="0">
                 <a:solidFill>
                   <a:srgbClr val="000000"/>
                 </a:solidFill>
@@ -6951,7 +6951,7 @@
           <a:p>
             <a:pPr algn="l">
               <a:lnSpc>
-                <a:spcPts val="1820"/>
+                <a:spcPts val="2080"/>
               </a:lnSpc>
               <a:spcBef>
                 <a:spcPts val="0"/>
@@ -6961,7 +6961,7 @@
               </a:spcAft>
             </a:pPr>
             <a:r>
-              <a:rPr sz="1400" b="1">
+              <a:rPr sz="1600" b="1">
                 <a:solidFill>
                   <a:srgbClr val="1B3A5C"/>
                 </a:solidFill>
@@ -6973,7 +6973,7 @@
           <a:p>
             <a:pPr algn="l">
               <a:lnSpc>
-                <a:spcPts val="1820"/>
+                <a:spcPts val="2080"/>
               </a:lnSpc>
               <a:spcBef>
                 <a:spcPts val="800"/>
@@ -6983,7 +6983,7 @@
               </a:spcAft>
             </a:pPr>
             <a:r>
-              <a:rPr sz="1400" b="1">
+              <a:rPr sz="1600" b="1">
                 <a:solidFill>
                   <a:srgbClr val="333333"/>
                 </a:solidFill>
@@ -6995,17 +6995,17 @@
           <a:p>
             <a:pPr algn="l">
               <a:lnSpc>
-                <a:spcPts val="1430"/>
-              </a:lnSpc>
-              <a:spcBef>
-                <a:spcPts val="200"/>
-              </a:spcBef>
-              <a:spcAft>
-                <a:spcPts val="200"/>
-              </a:spcAft>
-            </a:pPr>
-            <a:r>
-              <a:rPr sz="1100" b="0">
+                <a:spcPts val="1820"/>
+              </a:lnSpc>
+              <a:spcBef>
+                <a:spcPts val="200"/>
+              </a:spcBef>
+              <a:spcAft>
+                <a:spcPts val="200"/>
+              </a:spcAft>
+            </a:pPr>
+            <a:r>
+              <a:rPr sz="1400" b="0">
                 <a:solidFill>
                   <a:srgbClr val="000000"/>
                 </a:solidFill>
@@ -7017,7 +7017,7 @@
           <a:p>
             <a:pPr algn="l">
               <a:lnSpc>
-                <a:spcPts val="1820"/>
+                <a:spcPts val="2080"/>
               </a:lnSpc>
               <a:spcBef>
                 <a:spcPts val="800"/>
@@ -7027,7 +7027,7 @@
               </a:spcAft>
             </a:pPr>
             <a:r>
-              <a:rPr sz="1400" b="1">
+              <a:rPr sz="1600" b="1">
                 <a:solidFill>
                   <a:srgbClr val="1B5C9E"/>
                 </a:solidFill>
@@ -7039,17 +7039,17 @@
           <a:p>
             <a:pPr algn="l">
               <a:lnSpc>
-                <a:spcPts val="1430"/>
-              </a:lnSpc>
-              <a:spcBef>
-                <a:spcPts val="200"/>
-              </a:spcBef>
-              <a:spcAft>
-                <a:spcPts val="200"/>
-              </a:spcAft>
-            </a:pPr>
-            <a:r>
-              <a:rPr sz="1100" b="0">
+                <a:spcPts val="1820"/>
+              </a:lnSpc>
+              <a:spcBef>
+                <a:spcPts val="200"/>
+              </a:spcBef>
+              <a:spcAft>
+                <a:spcPts val="200"/>
+              </a:spcAft>
+            </a:pPr>
+            <a:r>
+              <a:rPr sz="1400" b="0">
                 <a:solidFill>
                   <a:srgbClr val="000000"/>
                 </a:solidFill>
@@ -7061,17 +7061,17 @@
           <a:p>
             <a:pPr algn="l">
               <a:lnSpc>
-                <a:spcPts val="1430"/>
-              </a:lnSpc>
-              <a:spcBef>
-                <a:spcPts val="200"/>
-              </a:spcBef>
-              <a:spcAft>
-                <a:spcPts val="200"/>
-              </a:spcAft>
-            </a:pPr>
-            <a:r>
-              <a:rPr sz="1100" b="0">
+                <a:spcPts val="1820"/>
+              </a:lnSpc>
+              <a:spcBef>
+                <a:spcPts val="200"/>
+              </a:spcBef>
+              <a:spcAft>
+                <a:spcPts val="200"/>
+              </a:spcAft>
+            </a:pPr>
+            <a:r>
+              <a:rPr sz="1400" b="0">
                 <a:solidFill>
                   <a:srgbClr val="000000"/>
                 </a:solidFill>
@@ -7083,17 +7083,17 @@
           <a:p>
             <a:pPr algn="l">
               <a:lnSpc>
-                <a:spcPts val="1430"/>
-              </a:lnSpc>
-              <a:spcBef>
-                <a:spcPts val="200"/>
-              </a:spcBef>
-              <a:spcAft>
-                <a:spcPts val="200"/>
-              </a:spcAft>
-            </a:pPr>
-            <a:r>
-              <a:rPr sz="1100" b="0">
+                <a:spcPts val="1820"/>
+              </a:lnSpc>
+              <a:spcBef>
+                <a:spcPts val="200"/>
+              </a:spcBef>
+              <a:spcAft>
+                <a:spcPts val="200"/>
+              </a:spcAft>
+            </a:pPr>
+            <a:r>
+              <a:rPr sz="1400" b="0">
                 <a:solidFill>
                   <a:srgbClr val="000000"/>
                 </a:solidFill>
@@ -7105,17 +7105,17 @@
           <a:p>
             <a:pPr algn="l">
               <a:lnSpc>
-                <a:spcPts val="1430"/>
-              </a:lnSpc>
-              <a:spcBef>
-                <a:spcPts val="200"/>
-              </a:spcBef>
-              <a:spcAft>
-                <a:spcPts val="200"/>
-              </a:spcAft>
-            </a:pPr>
-            <a:r>
-              <a:rPr sz="1100" b="0">
+                <a:spcPts val="1820"/>
+              </a:lnSpc>
+              <a:spcBef>
+                <a:spcPts val="200"/>
+              </a:spcBef>
+              <a:spcAft>
+                <a:spcPts val="200"/>
+              </a:spcAft>
+            </a:pPr>
+            <a:r>
+              <a:rPr sz="1400" b="0">
                 <a:solidFill>
                   <a:srgbClr val="000000"/>
                 </a:solidFill>
@@ -7127,7 +7127,7 @@
           <a:p>
             <a:pPr algn="l">
               <a:lnSpc>
-                <a:spcPts val="1820"/>
+                <a:spcPts val="2080"/>
               </a:lnSpc>
               <a:spcBef>
                 <a:spcPts val="800"/>
@@ -7137,7 +7137,7 @@
               </a:spcAft>
             </a:pPr>
             <a:r>
-              <a:rPr sz="1400" b="1">
+              <a:rPr sz="1600" b="1">
                 <a:solidFill>
                   <a:srgbClr val="CC3333"/>
                 </a:solidFill>
@@ -7149,17 +7149,17 @@
           <a:p>
             <a:pPr algn="l">
               <a:lnSpc>
-                <a:spcPts val="1430"/>
-              </a:lnSpc>
-              <a:spcBef>
-                <a:spcPts val="200"/>
-              </a:spcBef>
-              <a:spcAft>
-                <a:spcPts val="200"/>
-              </a:spcAft>
-            </a:pPr>
-            <a:r>
-              <a:rPr sz="1100" b="0">
+                <a:spcPts val="1820"/>
+              </a:lnSpc>
+              <a:spcBef>
+                <a:spcPts val="200"/>
+              </a:spcBef>
+              <a:spcAft>
+                <a:spcPts val="200"/>
+              </a:spcAft>
+            </a:pPr>
+            <a:r>
+              <a:rPr sz="1400" b="0">
                 <a:solidFill>
                   <a:srgbClr val="000000"/>
                 </a:solidFill>
@@ -7171,7 +7171,7 @@
           <a:p>
             <a:pPr algn="l">
               <a:lnSpc>
-                <a:spcPts val="1820"/>
+                <a:spcPts val="2080"/>
               </a:lnSpc>
               <a:spcBef>
                 <a:spcPts val="800"/>
@@ -7181,7 +7181,7 @@
               </a:spcAft>
             </a:pPr>
             <a:r>
-              <a:rPr sz="1400" b="1">
+              <a:rPr sz="1600" b="1">
                 <a:solidFill>
                   <a:srgbClr val="008040"/>
                 </a:solidFill>
@@ -7193,17 +7193,17 @@
           <a:p>
             <a:pPr algn="l">
               <a:lnSpc>
-                <a:spcPts val="1430"/>
-              </a:lnSpc>
-              <a:spcBef>
-                <a:spcPts val="200"/>
-              </a:spcBef>
-              <a:spcAft>
-                <a:spcPts val="200"/>
-              </a:spcAft>
-            </a:pPr>
-            <a:r>
-              <a:rPr sz="1100" b="0">
+                <a:spcPts val="1820"/>
+              </a:lnSpc>
+              <a:spcBef>
+                <a:spcPts val="200"/>
+              </a:spcBef>
+              <a:spcAft>
+                <a:spcPts val="200"/>
+              </a:spcAft>
+            </a:pPr>
+            <a:r>
+              <a:rPr sz="1400" b="0">
                 <a:solidFill>
                   <a:srgbClr val="000000"/>
                 </a:solidFill>
@@ -7308,7 +7308,7 @@
           <a:p>
             <a:pPr algn="l">
               <a:lnSpc>
-                <a:spcPts val="1820"/>
+                <a:spcPts val="2080"/>
               </a:lnSpc>
               <a:spcBef>
                 <a:spcPts val="0"/>
@@ -7318,7 +7318,7 @@
               </a:spcAft>
             </a:pPr>
             <a:r>
-              <a:rPr sz="1400" b="1">
+              <a:rPr sz="1600" b="1">
                 <a:solidFill>
                   <a:srgbClr val="1B3A5C"/>
                 </a:solidFill>
@@ -7330,7 +7330,7 @@
           <a:p>
             <a:pPr algn="l">
               <a:lnSpc>
-                <a:spcPts val="1820"/>
+                <a:spcPts val="2080"/>
               </a:lnSpc>
               <a:spcBef>
                 <a:spcPts val="800"/>
@@ -7340,7 +7340,7 @@
               </a:spcAft>
             </a:pPr>
             <a:r>
-              <a:rPr sz="1400" b="1">
+              <a:rPr sz="1600" b="1">
                 <a:solidFill>
                   <a:srgbClr val="333333"/>
                 </a:solidFill>
@@ -7352,17 +7352,17 @@
           <a:p>
             <a:pPr algn="l">
               <a:lnSpc>
-                <a:spcPts val="1430"/>
-              </a:lnSpc>
-              <a:spcBef>
-                <a:spcPts val="200"/>
-              </a:spcBef>
-              <a:spcAft>
-                <a:spcPts val="200"/>
-              </a:spcAft>
-            </a:pPr>
-            <a:r>
-              <a:rPr sz="1100" b="0">
+                <a:spcPts val="1820"/>
+              </a:lnSpc>
+              <a:spcBef>
+                <a:spcPts val="200"/>
+              </a:spcBef>
+              <a:spcAft>
+                <a:spcPts val="200"/>
+              </a:spcAft>
+            </a:pPr>
+            <a:r>
+              <a:rPr sz="1400" b="0">
                 <a:solidFill>
                   <a:srgbClr val="000000"/>
                 </a:solidFill>
@@ -7374,7 +7374,7 @@
           <a:p>
             <a:pPr algn="l">
               <a:lnSpc>
-                <a:spcPts val="1820"/>
+                <a:spcPts val="2080"/>
               </a:lnSpc>
               <a:spcBef>
                 <a:spcPts val="800"/>
@@ -7384,7 +7384,7 @@
               </a:spcAft>
             </a:pPr>
             <a:r>
-              <a:rPr sz="1400" b="1">
+              <a:rPr sz="1600" b="1">
                 <a:solidFill>
                   <a:srgbClr val="1B5C9E"/>
                 </a:solidFill>
@@ -7396,17 +7396,17 @@
           <a:p>
             <a:pPr algn="l">
               <a:lnSpc>
-                <a:spcPts val="1430"/>
-              </a:lnSpc>
-              <a:spcBef>
-                <a:spcPts val="200"/>
-              </a:spcBef>
-              <a:spcAft>
-                <a:spcPts val="200"/>
-              </a:spcAft>
-            </a:pPr>
-            <a:r>
-              <a:rPr sz="1100" b="0">
+                <a:spcPts val="1820"/>
+              </a:lnSpc>
+              <a:spcBef>
+                <a:spcPts val="200"/>
+              </a:spcBef>
+              <a:spcAft>
+                <a:spcPts val="200"/>
+              </a:spcAft>
+            </a:pPr>
+            <a:r>
+              <a:rPr sz="1400" b="0">
                 <a:solidFill>
                   <a:srgbClr val="000000"/>
                 </a:solidFill>
@@ -7418,17 +7418,17 @@
           <a:p>
             <a:pPr algn="l">
               <a:lnSpc>
-                <a:spcPts val="1430"/>
-              </a:lnSpc>
-              <a:spcBef>
-                <a:spcPts val="200"/>
-              </a:spcBef>
-              <a:spcAft>
-                <a:spcPts val="200"/>
-              </a:spcAft>
-            </a:pPr>
-            <a:r>
-              <a:rPr sz="1100" b="0">
+                <a:spcPts val="1820"/>
+              </a:lnSpc>
+              <a:spcBef>
+                <a:spcPts val="200"/>
+              </a:spcBef>
+              <a:spcAft>
+                <a:spcPts val="200"/>
+              </a:spcAft>
+            </a:pPr>
+            <a:r>
+              <a:rPr sz="1400" b="0">
                 <a:solidFill>
                   <a:srgbClr val="000000"/>
                 </a:solidFill>
@@ -7440,17 +7440,17 @@
           <a:p>
             <a:pPr algn="l">
               <a:lnSpc>
-                <a:spcPts val="1430"/>
-              </a:lnSpc>
-              <a:spcBef>
-                <a:spcPts val="200"/>
-              </a:spcBef>
-              <a:spcAft>
-                <a:spcPts val="200"/>
-              </a:spcAft>
-            </a:pPr>
-            <a:r>
-              <a:rPr sz="1100" b="0">
+                <a:spcPts val="1820"/>
+              </a:lnSpc>
+              <a:spcBef>
+                <a:spcPts val="200"/>
+              </a:spcBef>
+              <a:spcAft>
+                <a:spcPts val="200"/>
+              </a:spcAft>
+            </a:pPr>
+            <a:r>
+              <a:rPr sz="1400" b="0">
                 <a:solidFill>
                   <a:srgbClr val="000000"/>
                 </a:solidFill>
@@ -7462,17 +7462,17 @@
           <a:p>
             <a:pPr algn="l">
               <a:lnSpc>
-                <a:spcPts val="1430"/>
-              </a:lnSpc>
-              <a:spcBef>
-                <a:spcPts val="200"/>
-              </a:spcBef>
-              <a:spcAft>
-                <a:spcPts val="200"/>
-              </a:spcAft>
-            </a:pPr>
-            <a:r>
-              <a:rPr sz="1100" b="0">
+                <a:spcPts val="1820"/>
+              </a:lnSpc>
+              <a:spcBef>
+                <a:spcPts val="200"/>
+              </a:spcBef>
+              <a:spcAft>
+                <a:spcPts val="200"/>
+              </a:spcAft>
+            </a:pPr>
+            <a:r>
+              <a:rPr sz="1400" b="0">
                 <a:solidFill>
                   <a:srgbClr val="000000"/>
                 </a:solidFill>
@@ -7484,7 +7484,7 @@
           <a:p>
             <a:pPr algn="l">
               <a:lnSpc>
-                <a:spcPts val="1820"/>
+                <a:spcPts val="2080"/>
               </a:lnSpc>
               <a:spcBef>
                 <a:spcPts val="800"/>
@@ -7494,7 +7494,7 @@
               </a:spcAft>
             </a:pPr>
             <a:r>
-              <a:rPr sz="1400" b="1">
+              <a:rPr sz="1600" b="1">
                 <a:solidFill>
                   <a:srgbClr val="CC3333"/>
                 </a:solidFill>
@@ -7506,17 +7506,17 @@
           <a:p>
             <a:pPr algn="l">
               <a:lnSpc>
-                <a:spcPts val="1430"/>
-              </a:lnSpc>
-              <a:spcBef>
-                <a:spcPts val="200"/>
-              </a:spcBef>
-              <a:spcAft>
-                <a:spcPts val="200"/>
-              </a:spcAft>
-            </a:pPr>
-            <a:r>
-              <a:rPr sz="1100" b="0">
+                <a:spcPts val="1820"/>
+              </a:lnSpc>
+              <a:spcBef>
+                <a:spcPts val="200"/>
+              </a:spcBef>
+              <a:spcAft>
+                <a:spcPts val="200"/>
+              </a:spcAft>
+            </a:pPr>
+            <a:r>
+              <a:rPr sz="1400" b="0">
                 <a:solidFill>
                   <a:srgbClr val="000000"/>
                 </a:solidFill>
@@ -7528,7 +7528,7 @@
           <a:p>
             <a:pPr algn="l">
               <a:lnSpc>
-                <a:spcPts val="1820"/>
+                <a:spcPts val="2080"/>
               </a:lnSpc>
               <a:spcBef>
                 <a:spcPts val="800"/>
@@ -7538,7 +7538,7 @@
               </a:spcAft>
             </a:pPr>
             <a:r>
-              <a:rPr sz="1400" b="1">
+              <a:rPr sz="1600" b="1">
                 <a:solidFill>
                   <a:srgbClr val="008040"/>
                 </a:solidFill>
@@ -7550,17 +7550,17 @@
           <a:p>
             <a:pPr algn="l">
               <a:lnSpc>
-                <a:spcPts val="1430"/>
-              </a:lnSpc>
-              <a:spcBef>
-                <a:spcPts val="200"/>
-              </a:spcBef>
-              <a:spcAft>
-                <a:spcPts val="200"/>
-              </a:spcAft>
-            </a:pPr>
-            <a:r>
-              <a:rPr sz="1100" b="0">
+                <a:spcPts val="1820"/>
+              </a:lnSpc>
+              <a:spcBef>
+                <a:spcPts val="200"/>
+              </a:spcBef>
+              <a:spcAft>
+                <a:spcPts val="200"/>
+              </a:spcAft>
+            </a:pPr>
+            <a:r>
+              <a:rPr sz="1400" b="0">
                 <a:solidFill>
                   <a:srgbClr val="000000"/>
                 </a:solidFill>
@@ -7665,7 +7665,7 @@
           <a:p>
             <a:pPr algn="l">
               <a:lnSpc>
-                <a:spcPts val="1820"/>
+                <a:spcPts val="2080"/>
               </a:lnSpc>
               <a:spcBef>
                 <a:spcPts val="0"/>
@@ -7675,7 +7675,7 @@
               </a:spcAft>
             </a:pPr>
             <a:r>
-              <a:rPr sz="1400" b="1">
+              <a:rPr sz="1600" b="1">
                 <a:solidFill>
                   <a:srgbClr val="1B3A5C"/>
                 </a:solidFill>
@@ -7687,7 +7687,7 @@
           <a:p>
             <a:pPr algn="l">
               <a:lnSpc>
-                <a:spcPts val="1820"/>
+                <a:spcPts val="2080"/>
               </a:lnSpc>
               <a:spcBef>
                 <a:spcPts val="800"/>
@@ -7697,7 +7697,7 @@
               </a:spcAft>
             </a:pPr>
             <a:r>
-              <a:rPr sz="1400" b="1">
+              <a:rPr sz="1600" b="1">
                 <a:solidFill>
                   <a:srgbClr val="333333"/>
                 </a:solidFill>
@@ -7709,17 +7709,17 @@
           <a:p>
             <a:pPr algn="l">
               <a:lnSpc>
-                <a:spcPts val="1430"/>
-              </a:lnSpc>
-              <a:spcBef>
-                <a:spcPts val="200"/>
-              </a:spcBef>
-              <a:spcAft>
-                <a:spcPts val="200"/>
-              </a:spcAft>
-            </a:pPr>
-            <a:r>
-              <a:rPr sz="1100" b="0">
+                <a:spcPts val="1820"/>
+              </a:lnSpc>
+              <a:spcBef>
+                <a:spcPts val="200"/>
+              </a:spcBef>
+              <a:spcAft>
+                <a:spcPts val="200"/>
+              </a:spcAft>
+            </a:pPr>
+            <a:r>
+              <a:rPr sz="1400" b="0">
                 <a:solidFill>
                   <a:srgbClr val="000000"/>
                 </a:solidFill>
@@ -7731,7 +7731,7 @@
           <a:p>
             <a:pPr algn="l">
               <a:lnSpc>
-                <a:spcPts val="1820"/>
+                <a:spcPts val="2080"/>
               </a:lnSpc>
               <a:spcBef>
                 <a:spcPts val="800"/>
@@ -7741,7 +7741,7 @@
               </a:spcAft>
             </a:pPr>
             <a:r>
-              <a:rPr sz="1400" b="1">
+              <a:rPr sz="1600" b="1">
                 <a:solidFill>
                   <a:srgbClr val="1B5C9E"/>
                 </a:solidFill>
@@ -7753,17 +7753,17 @@
           <a:p>
             <a:pPr algn="l">
               <a:lnSpc>
-                <a:spcPts val="1430"/>
-              </a:lnSpc>
-              <a:spcBef>
-                <a:spcPts val="200"/>
-              </a:spcBef>
-              <a:spcAft>
-                <a:spcPts val="200"/>
-              </a:spcAft>
-            </a:pPr>
-            <a:r>
-              <a:rPr sz="1100" b="0">
+                <a:spcPts val="1820"/>
+              </a:lnSpc>
+              <a:spcBef>
+                <a:spcPts val="200"/>
+              </a:spcBef>
+              <a:spcAft>
+                <a:spcPts val="200"/>
+              </a:spcAft>
+            </a:pPr>
+            <a:r>
+              <a:rPr sz="1400" b="0">
                 <a:solidFill>
                   <a:srgbClr val="000000"/>
                 </a:solidFill>
@@ -7775,17 +7775,17 @@
           <a:p>
             <a:pPr algn="l">
               <a:lnSpc>
-                <a:spcPts val="1430"/>
-              </a:lnSpc>
-              <a:spcBef>
-                <a:spcPts val="200"/>
-              </a:spcBef>
-              <a:spcAft>
-                <a:spcPts val="200"/>
-              </a:spcAft>
-            </a:pPr>
-            <a:r>
-              <a:rPr sz="1100" b="0">
+                <a:spcPts val="1820"/>
+              </a:lnSpc>
+              <a:spcBef>
+                <a:spcPts val="200"/>
+              </a:spcBef>
+              <a:spcAft>
+                <a:spcPts val="200"/>
+              </a:spcAft>
+            </a:pPr>
+            <a:r>
+              <a:rPr sz="1400" b="0">
                 <a:solidFill>
                   <a:srgbClr val="000000"/>
                 </a:solidFill>
@@ -7797,17 +7797,17 @@
           <a:p>
             <a:pPr algn="l">
               <a:lnSpc>
-                <a:spcPts val="1430"/>
-              </a:lnSpc>
-              <a:spcBef>
-                <a:spcPts val="200"/>
-              </a:spcBef>
-              <a:spcAft>
-                <a:spcPts val="200"/>
-              </a:spcAft>
-            </a:pPr>
-            <a:r>
-              <a:rPr sz="1100" b="0">
+                <a:spcPts val="1820"/>
+              </a:lnSpc>
+              <a:spcBef>
+                <a:spcPts val="200"/>
+              </a:spcBef>
+              <a:spcAft>
+                <a:spcPts val="200"/>
+              </a:spcAft>
+            </a:pPr>
+            <a:r>
+              <a:rPr sz="1400" b="0">
                 <a:solidFill>
                   <a:srgbClr val="000000"/>
                 </a:solidFill>
@@ -7819,7 +7819,7 @@
           <a:p>
             <a:pPr algn="l">
               <a:lnSpc>
-                <a:spcPts val="1820"/>
+                <a:spcPts val="2080"/>
               </a:lnSpc>
               <a:spcBef>
                 <a:spcPts val="800"/>
@@ -7829,7 +7829,7 @@
               </a:spcAft>
             </a:pPr>
             <a:r>
-              <a:rPr sz="1400" b="1">
+              <a:rPr sz="1600" b="1">
                 <a:solidFill>
                   <a:srgbClr val="CC3333"/>
                 </a:solidFill>
@@ -7841,17 +7841,17 @@
           <a:p>
             <a:pPr algn="l">
               <a:lnSpc>
-                <a:spcPts val="1430"/>
-              </a:lnSpc>
-              <a:spcBef>
-                <a:spcPts val="200"/>
-              </a:spcBef>
-              <a:spcAft>
-                <a:spcPts val="200"/>
-              </a:spcAft>
-            </a:pPr>
-            <a:r>
-              <a:rPr sz="1100" b="0">
+                <a:spcPts val="1820"/>
+              </a:lnSpc>
+              <a:spcBef>
+                <a:spcPts val="200"/>
+              </a:spcBef>
+              <a:spcAft>
+                <a:spcPts val="200"/>
+              </a:spcAft>
+            </a:pPr>
+            <a:r>
+              <a:rPr sz="1400" b="0">
                 <a:solidFill>
                   <a:srgbClr val="000000"/>
                 </a:solidFill>
@@ -7863,7 +7863,7 @@
           <a:p>
             <a:pPr algn="l">
               <a:lnSpc>
-                <a:spcPts val="1820"/>
+                <a:spcPts val="2080"/>
               </a:lnSpc>
               <a:spcBef>
                 <a:spcPts val="800"/>
@@ -7873,7 +7873,7 @@
               </a:spcAft>
             </a:pPr>
             <a:r>
-              <a:rPr sz="1400" b="1">
+              <a:rPr sz="1600" b="1">
                 <a:solidFill>
                   <a:srgbClr val="008040"/>
                 </a:solidFill>
@@ -7885,17 +7885,17 @@
           <a:p>
             <a:pPr algn="l">
               <a:lnSpc>
-                <a:spcPts val="1430"/>
-              </a:lnSpc>
-              <a:spcBef>
-                <a:spcPts val="200"/>
-              </a:spcBef>
-              <a:spcAft>
-                <a:spcPts val="200"/>
-              </a:spcAft>
-            </a:pPr>
-            <a:r>
-              <a:rPr sz="1100" b="0">
+                <a:spcPts val="1820"/>
+              </a:lnSpc>
+              <a:spcBef>
+                <a:spcPts val="200"/>
+              </a:spcBef>
+              <a:spcAft>
+                <a:spcPts val="200"/>
+              </a:spcAft>
+            </a:pPr>
+            <a:r>
+              <a:rPr sz="1400" b="0">
                 <a:solidFill>
                   <a:srgbClr val="000000"/>
                 </a:solidFill>
@@ -8000,7 +8000,7 @@
           <a:p>
             <a:pPr algn="l">
               <a:lnSpc>
-                <a:spcPts val="1820"/>
+                <a:spcPts val="2080"/>
               </a:lnSpc>
               <a:spcBef>
                 <a:spcPts val="0"/>
@@ -8010,7 +8010,7 @@
               </a:spcAft>
             </a:pPr>
             <a:r>
-              <a:rPr sz="1400" b="1">
+              <a:rPr sz="1600" b="1">
                 <a:solidFill>
                   <a:srgbClr val="1B3A5C"/>
                 </a:solidFill>
@@ -8022,7 +8022,7 @@
           <a:p>
             <a:pPr algn="l">
               <a:lnSpc>
-                <a:spcPts val="1820"/>
+                <a:spcPts val="2080"/>
               </a:lnSpc>
               <a:spcBef>
                 <a:spcPts val="800"/>
@@ -8032,7 +8032,7 @@
               </a:spcAft>
             </a:pPr>
             <a:r>
-              <a:rPr sz="1400" b="1">
+              <a:rPr sz="1600" b="1">
                 <a:solidFill>
                   <a:srgbClr val="333333"/>
                 </a:solidFill>
@@ -8044,17 +8044,17 @@
           <a:p>
             <a:pPr algn="l">
               <a:lnSpc>
-                <a:spcPts val="1430"/>
-              </a:lnSpc>
-              <a:spcBef>
-                <a:spcPts val="200"/>
-              </a:spcBef>
-              <a:spcAft>
-                <a:spcPts val="200"/>
-              </a:spcAft>
-            </a:pPr>
-            <a:r>
-              <a:rPr sz="1100" b="0">
+                <a:spcPts val="1820"/>
+              </a:lnSpc>
+              <a:spcBef>
+                <a:spcPts val="200"/>
+              </a:spcBef>
+              <a:spcAft>
+                <a:spcPts val="200"/>
+              </a:spcAft>
+            </a:pPr>
+            <a:r>
+              <a:rPr sz="1400" b="0">
                 <a:solidFill>
                   <a:srgbClr val="000000"/>
                 </a:solidFill>
@@ -8066,7 +8066,7 @@
           <a:p>
             <a:pPr algn="l">
               <a:lnSpc>
-                <a:spcPts val="1820"/>
+                <a:spcPts val="2080"/>
               </a:lnSpc>
               <a:spcBef>
                 <a:spcPts val="800"/>
@@ -8076,7 +8076,7 @@
               </a:spcAft>
             </a:pPr>
             <a:r>
-              <a:rPr sz="1400" b="1">
+              <a:rPr sz="1600" b="1">
                 <a:solidFill>
                   <a:srgbClr val="1B5C9E"/>
                 </a:solidFill>
@@ -8088,17 +8088,17 @@
           <a:p>
             <a:pPr algn="l">
               <a:lnSpc>
-                <a:spcPts val="1430"/>
-              </a:lnSpc>
-              <a:spcBef>
-                <a:spcPts val="200"/>
-              </a:spcBef>
-              <a:spcAft>
-                <a:spcPts val="200"/>
-              </a:spcAft>
-            </a:pPr>
-            <a:r>
-              <a:rPr sz="1100" b="0">
+                <a:spcPts val="1820"/>
+              </a:lnSpc>
+              <a:spcBef>
+                <a:spcPts val="200"/>
+              </a:spcBef>
+              <a:spcAft>
+                <a:spcPts val="200"/>
+              </a:spcAft>
+            </a:pPr>
+            <a:r>
+              <a:rPr sz="1400" b="0">
                 <a:solidFill>
                   <a:srgbClr val="000000"/>
                 </a:solidFill>
@@ -8110,17 +8110,17 @@
           <a:p>
             <a:pPr algn="l">
               <a:lnSpc>
-                <a:spcPts val="1430"/>
-              </a:lnSpc>
-              <a:spcBef>
-                <a:spcPts val="200"/>
-              </a:spcBef>
-              <a:spcAft>
-                <a:spcPts val="200"/>
-              </a:spcAft>
-            </a:pPr>
-            <a:r>
-              <a:rPr sz="1100" b="0">
+                <a:spcPts val="1820"/>
+              </a:lnSpc>
+              <a:spcBef>
+                <a:spcPts val="200"/>
+              </a:spcBef>
+              <a:spcAft>
+                <a:spcPts val="200"/>
+              </a:spcAft>
+            </a:pPr>
+            <a:r>
+              <a:rPr sz="1400" b="0">
                 <a:solidFill>
                   <a:srgbClr val="000000"/>
                 </a:solidFill>
@@ -8132,17 +8132,17 @@
           <a:p>
             <a:pPr algn="l">
               <a:lnSpc>
-                <a:spcPts val="1430"/>
-              </a:lnSpc>
-              <a:spcBef>
-                <a:spcPts val="200"/>
-              </a:spcBef>
-              <a:spcAft>
-                <a:spcPts val="200"/>
-              </a:spcAft>
-            </a:pPr>
-            <a:r>
-              <a:rPr sz="1100" b="0">
+                <a:spcPts val="1820"/>
+              </a:lnSpc>
+              <a:spcBef>
+                <a:spcPts val="200"/>
+              </a:spcBef>
+              <a:spcAft>
+                <a:spcPts val="200"/>
+              </a:spcAft>
+            </a:pPr>
+            <a:r>
+              <a:rPr sz="1400" b="0">
                 <a:solidFill>
                   <a:srgbClr val="000000"/>
                 </a:solidFill>
@@ -8154,17 +8154,17 @@
           <a:p>
             <a:pPr algn="l">
               <a:lnSpc>
-                <a:spcPts val="1430"/>
-              </a:lnSpc>
-              <a:spcBef>
-                <a:spcPts val="200"/>
-              </a:spcBef>
-              <a:spcAft>
-                <a:spcPts val="200"/>
-              </a:spcAft>
-            </a:pPr>
-            <a:r>
-              <a:rPr sz="1100" b="0">
+                <a:spcPts val="1820"/>
+              </a:lnSpc>
+              <a:spcBef>
+                <a:spcPts val="200"/>
+              </a:spcBef>
+              <a:spcAft>
+                <a:spcPts val="200"/>
+              </a:spcAft>
+            </a:pPr>
+            <a:r>
+              <a:rPr sz="1400" b="0">
                 <a:solidFill>
                   <a:srgbClr val="000000"/>
                 </a:solidFill>
@@ -8176,7 +8176,7 @@
           <a:p>
             <a:pPr algn="l">
               <a:lnSpc>
-                <a:spcPts val="1820"/>
+                <a:spcPts val="2080"/>
               </a:lnSpc>
               <a:spcBef>
                 <a:spcPts val="800"/>
@@ -8186,7 +8186,7 @@
               </a:spcAft>
             </a:pPr>
             <a:r>
-              <a:rPr sz="1400" b="1">
+              <a:rPr sz="1600" b="1">
                 <a:solidFill>
                   <a:srgbClr val="CC3333"/>
                 </a:solidFill>
@@ -8198,17 +8198,17 @@
           <a:p>
             <a:pPr algn="l">
               <a:lnSpc>
-                <a:spcPts val="1430"/>
-              </a:lnSpc>
-              <a:spcBef>
-                <a:spcPts val="200"/>
-              </a:spcBef>
-              <a:spcAft>
-                <a:spcPts val="200"/>
-              </a:spcAft>
-            </a:pPr>
-            <a:r>
-              <a:rPr sz="1100" b="0">
+                <a:spcPts val="1820"/>
+              </a:lnSpc>
+              <a:spcBef>
+                <a:spcPts val="200"/>
+              </a:spcBef>
+              <a:spcAft>
+                <a:spcPts val="200"/>
+              </a:spcAft>
+            </a:pPr>
+            <a:r>
+              <a:rPr sz="1400" b="0">
                 <a:solidFill>
                   <a:srgbClr val="000000"/>
                 </a:solidFill>
@@ -8220,7 +8220,7 @@
           <a:p>
             <a:pPr algn="l">
               <a:lnSpc>
-                <a:spcPts val="1820"/>
+                <a:spcPts val="2080"/>
               </a:lnSpc>
               <a:spcBef>
                 <a:spcPts val="800"/>
@@ -8230,7 +8230,7 @@
               </a:spcAft>
             </a:pPr>
             <a:r>
-              <a:rPr sz="1400" b="1">
+              <a:rPr sz="1600" b="1">
                 <a:solidFill>
                   <a:srgbClr val="008040"/>
                 </a:solidFill>
@@ -8242,17 +8242,17 @@
           <a:p>
             <a:pPr algn="l">
               <a:lnSpc>
-                <a:spcPts val="1430"/>
-              </a:lnSpc>
-              <a:spcBef>
-                <a:spcPts val="200"/>
-              </a:spcBef>
-              <a:spcAft>
-                <a:spcPts val="200"/>
-              </a:spcAft>
-            </a:pPr>
-            <a:r>
-              <a:rPr sz="1100" b="0">
+                <a:spcPts val="1820"/>
+              </a:lnSpc>
+              <a:spcBef>
+                <a:spcPts val="200"/>
+              </a:spcBef>
+              <a:spcAft>
+                <a:spcPts val="200"/>
+              </a:spcAft>
+            </a:pPr>
+            <a:r>
+              <a:rPr sz="1400" b="0">
                 <a:solidFill>
                   <a:srgbClr val="000000"/>
                 </a:solidFill>

</xml_diff>

<commit_message>
Remove all paragraph spacing (before/after set to 0)
Co-Authored-By: Claude <noreply@anthropic.com>
</commit_message>
<xml_diff>
--- a/ppts_output_v3/04_消费税风险指引.pptx
+++ b/ppts_output_v3/04_消费税风险指引.pptx
@@ -3315,7 +3315,7 @@
                 <a:spcPts val="0"/>
               </a:spcBef>
               <a:spcAft>
-                <a:spcPts val="600"/>
+                <a:spcPts val="0"/>
               </a:spcAft>
             </a:pPr>
             <a:r>
@@ -3334,10 +3334,10 @@
                 <a:spcPct val="125000"/>
               </a:lnSpc>
               <a:spcBef>
-                <a:spcPts val="800"/>
-              </a:spcBef>
-              <a:spcAft>
-                <a:spcPts val="300"/>
+                <a:spcPts val="0"/>
+              </a:spcBef>
+              <a:spcAft>
+                <a:spcPts val="0"/>
               </a:spcAft>
             </a:pPr>
             <a:r>
@@ -3356,10 +3356,10 @@
                 <a:spcPct val="125000"/>
               </a:lnSpc>
               <a:spcBef>
-                <a:spcPts val="200"/>
-              </a:spcBef>
-              <a:spcAft>
-                <a:spcPts val="200"/>
+                <a:spcPts val="0"/>
+              </a:spcBef>
+              <a:spcAft>
+                <a:spcPts val="0"/>
               </a:spcAft>
             </a:pPr>
             <a:r>
@@ -3378,10 +3378,10 @@
                 <a:spcPct val="125000"/>
               </a:lnSpc>
               <a:spcBef>
-                <a:spcPts val="800"/>
-              </a:spcBef>
-              <a:spcAft>
-                <a:spcPts val="300"/>
+                <a:spcPts val="0"/>
+              </a:spcBef>
+              <a:spcAft>
+                <a:spcPts val="0"/>
               </a:spcAft>
             </a:pPr>
             <a:r>
@@ -3400,10 +3400,10 @@
                 <a:spcPct val="125000"/>
               </a:lnSpc>
               <a:spcBef>
-                <a:spcPts val="200"/>
-              </a:spcBef>
-              <a:spcAft>
-                <a:spcPts val="200"/>
+                <a:spcPts val="0"/>
+              </a:spcBef>
+              <a:spcAft>
+                <a:spcPts val="0"/>
               </a:spcAft>
             </a:pPr>
             <a:r>
@@ -3422,10 +3422,10 @@
                 <a:spcPct val="125000"/>
               </a:lnSpc>
               <a:spcBef>
-                <a:spcPts val="200"/>
-              </a:spcBef>
-              <a:spcAft>
-                <a:spcPts val="200"/>
+                <a:spcPts val="0"/>
+              </a:spcBef>
+              <a:spcAft>
+                <a:spcPts val="0"/>
               </a:spcAft>
             </a:pPr>
             <a:r>
@@ -3444,10 +3444,10 @@
                 <a:spcPct val="125000"/>
               </a:lnSpc>
               <a:spcBef>
-                <a:spcPts val="200"/>
-              </a:spcBef>
-              <a:spcAft>
-                <a:spcPts val="200"/>
+                <a:spcPts val="0"/>
+              </a:spcBef>
+              <a:spcAft>
+                <a:spcPts val="0"/>
               </a:spcAft>
             </a:pPr>
             <a:r>
@@ -3466,10 +3466,10 @@
                 <a:spcPct val="125000"/>
               </a:lnSpc>
               <a:spcBef>
-                <a:spcPts val="800"/>
-              </a:spcBef>
-              <a:spcAft>
-                <a:spcPts val="300"/>
+                <a:spcPts val="0"/>
+              </a:spcBef>
+              <a:spcAft>
+                <a:spcPts val="0"/>
               </a:spcAft>
             </a:pPr>
             <a:r>
@@ -3488,10 +3488,10 @@
                 <a:spcPct val="125000"/>
               </a:lnSpc>
               <a:spcBef>
-                <a:spcPts val="200"/>
-              </a:spcBef>
-              <a:spcAft>
-                <a:spcPts val="200"/>
+                <a:spcPts val="0"/>
+              </a:spcBef>
+              <a:spcAft>
+                <a:spcPts val="0"/>
               </a:spcAft>
             </a:pPr>
             <a:r>
@@ -3510,10 +3510,10 @@
                 <a:spcPct val="125000"/>
               </a:lnSpc>
               <a:spcBef>
-                <a:spcPts val="800"/>
-              </a:spcBef>
-              <a:spcAft>
-                <a:spcPts val="300"/>
+                <a:spcPts val="0"/>
+              </a:spcBef>
+              <a:spcAft>
+                <a:spcPts val="0"/>
               </a:spcAft>
             </a:pPr>
             <a:r>
@@ -3532,10 +3532,10 @@
                 <a:spcPct val="125000"/>
               </a:lnSpc>
               <a:spcBef>
-                <a:spcPts val="200"/>
-              </a:spcBef>
-              <a:spcAft>
-                <a:spcPts val="200"/>
+                <a:spcPts val="0"/>
+              </a:spcBef>
+              <a:spcAft>
+                <a:spcPts val="0"/>
               </a:spcAft>
             </a:pPr>
             <a:r>
@@ -3649,7 +3649,7 @@
                 <a:spcPts val="0"/>
               </a:spcBef>
               <a:spcAft>
-                <a:spcPts val="600"/>
+                <a:spcPts val="0"/>
               </a:spcAft>
             </a:pPr>
             <a:r>
@@ -3668,10 +3668,10 @@
                 <a:spcPct val="125000"/>
               </a:lnSpc>
               <a:spcBef>
-                <a:spcPts val="800"/>
-              </a:spcBef>
-              <a:spcAft>
-                <a:spcPts val="300"/>
+                <a:spcPts val="0"/>
+              </a:spcBef>
+              <a:spcAft>
+                <a:spcPts val="0"/>
               </a:spcAft>
             </a:pPr>
             <a:r>
@@ -3690,10 +3690,10 @@
                 <a:spcPct val="125000"/>
               </a:lnSpc>
               <a:spcBef>
-                <a:spcPts val="200"/>
-              </a:spcBef>
-              <a:spcAft>
-                <a:spcPts val="200"/>
+                <a:spcPts val="0"/>
+              </a:spcBef>
+              <a:spcAft>
+                <a:spcPts val="0"/>
               </a:spcAft>
             </a:pPr>
             <a:r>
@@ -3712,10 +3712,10 @@
                 <a:spcPct val="125000"/>
               </a:lnSpc>
               <a:spcBef>
-                <a:spcPts val="800"/>
-              </a:spcBef>
-              <a:spcAft>
-                <a:spcPts val="300"/>
+                <a:spcPts val="0"/>
+              </a:spcBef>
+              <a:spcAft>
+                <a:spcPts val="0"/>
               </a:spcAft>
             </a:pPr>
             <a:r>
@@ -3734,10 +3734,10 @@
                 <a:spcPct val="125000"/>
               </a:lnSpc>
               <a:spcBef>
-                <a:spcPts val="200"/>
-              </a:spcBef>
-              <a:spcAft>
-                <a:spcPts val="200"/>
+                <a:spcPts val="0"/>
+              </a:spcBef>
+              <a:spcAft>
+                <a:spcPts val="0"/>
               </a:spcAft>
             </a:pPr>
             <a:r>
@@ -3756,10 +3756,10 @@
                 <a:spcPct val="125000"/>
               </a:lnSpc>
               <a:spcBef>
-                <a:spcPts val="800"/>
-              </a:spcBef>
-              <a:spcAft>
-                <a:spcPts val="300"/>
+                <a:spcPts val="0"/>
+              </a:spcBef>
+              <a:spcAft>
+                <a:spcPts val="0"/>
               </a:spcAft>
             </a:pPr>
             <a:r>
@@ -3778,10 +3778,10 @@
                 <a:spcPct val="125000"/>
               </a:lnSpc>
               <a:spcBef>
-                <a:spcPts val="200"/>
-              </a:spcBef>
-              <a:spcAft>
-                <a:spcPts val="200"/>
+                <a:spcPts val="0"/>
+              </a:spcBef>
+              <a:spcAft>
+                <a:spcPts val="0"/>
               </a:spcAft>
             </a:pPr>
             <a:r>
@@ -3800,10 +3800,10 @@
                 <a:spcPct val="125000"/>
               </a:lnSpc>
               <a:spcBef>
-                <a:spcPts val="800"/>
-              </a:spcBef>
-              <a:spcAft>
-                <a:spcPts val="300"/>
+                <a:spcPts val="0"/>
+              </a:spcBef>
+              <a:spcAft>
+                <a:spcPts val="0"/>
               </a:spcAft>
             </a:pPr>
             <a:r>
@@ -3822,10 +3822,10 @@
                 <a:spcPct val="125000"/>
               </a:lnSpc>
               <a:spcBef>
-                <a:spcPts val="200"/>
-              </a:spcBef>
-              <a:spcAft>
-                <a:spcPts val="200"/>
+                <a:spcPts val="0"/>
+              </a:spcBef>
+              <a:spcAft>
+                <a:spcPts val="0"/>
               </a:spcAft>
             </a:pPr>
             <a:r>
@@ -3939,7 +3939,7 @@
                 <a:spcPts val="0"/>
               </a:spcBef>
               <a:spcAft>
-                <a:spcPts val="600"/>
+                <a:spcPts val="0"/>
               </a:spcAft>
             </a:pPr>
             <a:r>
@@ -3958,10 +3958,10 @@
                 <a:spcPct val="125000"/>
               </a:lnSpc>
               <a:spcBef>
-                <a:spcPts val="800"/>
-              </a:spcBef>
-              <a:spcAft>
-                <a:spcPts val="300"/>
+                <a:spcPts val="0"/>
+              </a:spcBef>
+              <a:spcAft>
+                <a:spcPts val="0"/>
               </a:spcAft>
             </a:pPr>
             <a:r>
@@ -3980,10 +3980,10 @@
                 <a:spcPct val="125000"/>
               </a:lnSpc>
               <a:spcBef>
-                <a:spcPts val="200"/>
-              </a:spcBef>
-              <a:spcAft>
-                <a:spcPts val="200"/>
+                <a:spcPts val="0"/>
+              </a:spcBef>
+              <a:spcAft>
+                <a:spcPts val="0"/>
               </a:spcAft>
             </a:pPr>
             <a:r>
@@ -4002,10 +4002,10 @@
                 <a:spcPct val="125000"/>
               </a:lnSpc>
               <a:spcBef>
-                <a:spcPts val="800"/>
-              </a:spcBef>
-              <a:spcAft>
-                <a:spcPts val="300"/>
+                <a:spcPts val="0"/>
+              </a:spcBef>
+              <a:spcAft>
+                <a:spcPts val="0"/>
               </a:spcAft>
             </a:pPr>
             <a:r>
@@ -4024,10 +4024,10 @@
                 <a:spcPct val="125000"/>
               </a:lnSpc>
               <a:spcBef>
-                <a:spcPts val="200"/>
-              </a:spcBef>
-              <a:spcAft>
-                <a:spcPts val="200"/>
+                <a:spcPts val="0"/>
+              </a:spcBef>
+              <a:spcAft>
+                <a:spcPts val="0"/>
               </a:spcAft>
             </a:pPr>
             <a:r>
@@ -4046,10 +4046,10 @@
                 <a:spcPct val="125000"/>
               </a:lnSpc>
               <a:spcBef>
-                <a:spcPts val="200"/>
-              </a:spcBef>
-              <a:spcAft>
-                <a:spcPts val="200"/>
+                <a:spcPts val="0"/>
+              </a:spcBef>
+              <a:spcAft>
+                <a:spcPts val="0"/>
               </a:spcAft>
             </a:pPr>
             <a:r>
@@ -4068,10 +4068,10 @@
                 <a:spcPct val="125000"/>
               </a:lnSpc>
               <a:spcBef>
-                <a:spcPts val="800"/>
-              </a:spcBef>
-              <a:spcAft>
-                <a:spcPts val="300"/>
+                <a:spcPts val="0"/>
+              </a:spcBef>
+              <a:spcAft>
+                <a:spcPts val="0"/>
               </a:spcAft>
             </a:pPr>
             <a:r>
@@ -4090,10 +4090,10 @@
                 <a:spcPct val="125000"/>
               </a:lnSpc>
               <a:spcBef>
-                <a:spcPts val="200"/>
-              </a:spcBef>
-              <a:spcAft>
-                <a:spcPts val="200"/>
+                <a:spcPts val="0"/>
+              </a:spcBef>
+              <a:spcAft>
+                <a:spcPts val="0"/>
               </a:spcAft>
             </a:pPr>
             <a:r>
@@ -4112,10 +4112,10 @@
                 <a:spcPct val="125000"/>
               </a:lnSpc>
               <a:spcBef>
-                <a:spcPts val="800"/>
-              </a:spcBef>
-              <a:spcAft>
-                <a:spcPts val="300"/>
+                <a:spcPts val="0"/>
+              </a:spcBef>
+              <a:spcAft>
+                <a:spcPts val="0"/>
               </a:spcAft>
             </a:pPr>
             <a:r>
@@ -4134,10 +4134,10 @@
                 <a:spcPct val="125000"/>
               </a:lnSpc>
               <a:spcBef>
-                <a:spcPts val="200"/>
-              </a:spcBef>
-              <a:spcAft>
-                <a:spcPts val="200"/>
+                <a:spcPts val="0"/>
+              </a:spcBef>
+              <a:spcAft>
+                <a:spcPts val="0"/>
               </a:spcAft>
             </a:pPr>
             <a:r>
@@ -4251,7 +4251,7 @@
                 <a:spcPts val="0"/>
               </a:spcBef>
               <a:spcAft>
-                <a:spcPts val="600"/>
+                <a:spcPts val="0"/>
               </a:spcAft>
             </a:pPr>
             <a:r>
@@ -4270,10 +4270,10 @@
                 <a:spcPct val="125000"/>
               </a:lnSpc>
               <a:spcBef>
-                <a:spcPts val="800"/>
-              </a:spcBef>
-              <a:spcAft>
-                <a:spcPts val="300"/>
+                <a:spcPts val="0"/>
+              </a:spcBef>
+              <a:spcAft>
+                <a:spcPts val="0"/>
               </a:spcAft>
             </a:pPr>
             <a:r>
@@ -4292,10 +4292,10 @@
                 <a:spcPct val="125000"/>
               </a:lnSpc>
               <a:spcBef>
-                <a:spcPts val="200"/>
-              </a:spcBef>
-              <a:spcAft>
-                <a:spcPts val="200"/>
+                <a:spcPts val="0"/>
+              </a:spcBef>
+              <a:spcAft>
+                <a:spcPts val="0"/>
               </a:spcAft>
             </a:pPr>
             <a:r>
@@ -4314,10 +4314,10 @@
                 <a:spcPct val="125000"/>
               </a:lnSpc>
               <a:spcBef>
-                <a:spcPts val="800"/>
-              </a:spcBef>
-              <a:spcAft>
-                <a:spcPts val="300"/>
+                <a:spcPts val="0"/>
+              </a:spcBef>
+              <a:spcAft>
+                <a:spcPts val="0"/>
               </a:spcAft>
             </a:pPr>
             <a:r>
@@ -4336,10 +4336,10 @@
                 <a:spcPct val="125000"/>
               </a:lnSpc>
               <a:spcBef>
-                <a:spcPts val="200"/>
-              </a:spcBef>
-              <a:spcAft>
-                <a:spcPts val="200"/>
+                <a:spcPts val="0"/>
+              </a:spcBef>
+              <a:spcAft>
+                <a:spcPts val="0"/>
               </a:spcAft>
             </a:pPr>
             <a:r>
@@ -4358,10 +4358,10 @@
                 <a:spcPct val="125000"/>
               </a:lnSpc>
               <a:spcBef>
-                <a:spcPts val="800"/>
-              </a:spcBef>
-              <a:spcAft>
-                <a:spcPts val="300"/>
+                <a:spcPts val="0"/>
+              </a:spcBef>
+              <a:spcAft>
+                <a:spcPts val="0"/>
               </a:spcAft>
             </a:pPr>
             <a:r>
@@ -4380,10 +4380,10 @@
                 <a:spcPct val="125000"/>
               </a:lnSpc>
               <a:spcBef>
-                <a:spcPts val="200"/>
-              </a:spcBef>
-              <a:spcAft>
-                <a:spcPts val="200"/>
+                <a:spcPts val="0"/>
+              </a:spcBef>
+              <a:spcAft>
+                <a:spcPts val="0"/>
               </a:spcAft>
             </a:pPr>
             <a:r>
@@ -4402,10 +4402,10 @@
                 <a:spcPct val="125000"/>
               </a:lnSpc>
               <a:spcBef>
-                <a:spcPts val="800"/>
-              </a:spcBef>
-              <a:spcAft>
-                <a:spcPts val="300"/>
+                <a:spcPts val="0"/>
+              </a:spcBef>
+              <a:spcAft>
+                <a:spcPts val="0"/>
               </a:spcAft>
             </a:pPr>
             <a:r>
@@ -4424,10 +4424,10 @@
                 <a:spcPct val="125000"/>
               </a:lnSpc>
               <a:spcBef>
-                <a:spcPts val="200"/>
-              </a:spcBef>
-              <a:spcAft>
-                <a:spcPts val="200"/>
+                <a:spcPts val="0"/>
+              </a:spcBef>
+              <a:spcAft>
+                <a:spcPts val="0"/>
               </a:spcAft>
             </a:pPr>
             <a:r>
@@ -4541,7 +4541,7 @@
                 <a:spcPts val="0"/>
               </a:spcBef>
               <a:spcAft>
-                <a:spcPts val="600"/>
+                <a:spcPts val="0"/>
               </a:spcAft>
             </a:pPr>
             <a:r>
@@ -4560,10 +4560,10 @@
                 <a:spcPct val="125000"/>
               </a:lnSpc>
               <a:spcBef>
-                <a:spcPts val="800"/>
-              </a:spcBef>
-              <a:spcAft>
-                <a:spcPts val="300"/>
+                <a:spcPts val="0"/>
+              </a:spcBef>
+              <a:spcAft>
+                <a:spcPts val="0"/>
               </a:spcAft>
             </a:pPr>
             <a:r>
@@ -4582,10 +4582,10 @@
                 <a:spcPct val="125000"/>
               </a:lnSpc>
               <a:spcBef>
-                <a:spcPts val="200"/>
-              </a:spcBef>
-              <a:spcAft>
-                <a:spcPts val="200"/>
+                <a:spcPts val="0"/>
+              </a:spcBef>
+              <a:spcAft>
+                <a:spcPts val="0"/>
               </a:spcAft>
             </a:pPr>
             <a:r>
@@ -4604,10 +4604,10 @@
                 <a:spcPct val="125000"/>
               </a:lnSpc>
               <a:spcBef>
-                <a:spcPts val="800"/>
-              </a:spcBef>
-              <a:spcAft>
-                <a:spcPts val="300"/>
+                <a:spcPts val="0"/>
+              </a:spcBef>
+              <a:spcAft>
+                <a:spcPts val="0"/>
               </a:spcAft>
             </a:pPr>
             <a:r>
@@ -4626,10 +4626,10 @@
                 <a:spcPct val="125000"/>
               </a:lnSpc>
               <a:spcBef>
-                <a:spcPts val="200"/>
-              </a:spcBef>
-              <a:spcAft>
-                <a:spcPts val="200"/>
+                <a:spcPts val="0"/>
+              </a:spcBef>
+              <a:spcAft>
+                <a:spcPts val="0"/>
               </a:spcAft>
             </a:pPr>
             <a:r>
@@ -4648,10 +4648,10 @@
                 <a:spcPct val="125000"/>
               </a:lnSpc>
               <a:spcBef>
-                <a:spcPts val="200"/>
-              </a:spcBef>
-              <a:spcAft>
-                <a:spcPts val="200"/>
+                <a:spcPts val="0"/>
+              </a:spcBef>
+              <a:spcAft>
+                <a:spcPts val="0"/>
               </a:spcAft>
             </a:pPr>
             <a:r>
@@ -4670,10 +4670,10 @@
                 <a:spcPct val="125000"/>
               </a:lnSpc>
               <a:spcBef>
-                <a:spcPts val="800"/>
-              </a:spcBef>
-              <a:spcAft>
-                <a:spcPts val="300"/>
+                <a:spcPts val="0"/>
+              </a:spcBef>
+              <a:spcAft>
+                <a:spcPts val="0"/>
               </a:spcAft>
             </a:pPr>
             <a:r>
@@ -4692,10 +4692,10 @@
                 <a:spcPct val="125000"/>
               </a:lnSpc>
               <a:spcBef>
-                <a:spcPts val="200"/>
-              </a:spcBef>
-              <a:spcAft>
-                <a:spcPts val="200"/>
+                <a:spcPts val="0"/>
+              </a:spcBef>
+              <a:spcAft>
+                <a:spcPts val="0"/>
               </a:spcAft>
             </a:pPr>
             <a:r>
@@ -4714,10 +4714,10 @@
                 <a:spcPct val="125000"/>
               </a:lnSpc>
               <a:spcBef>
-                <a:spcPts val="800"/>
-              </a:spcBef>
-              <a:spcAft>
-                <a:spcPts val="300"/>
+                <a:spcPts val="0"/>
+              </a:spcBef>
+              <a:spcAft>
+                <a:spcPts val="0"/>
               </a:spcAft>
             </a:pPr>
             <a:r>
@@ -4736,10 +4736,10 @@
                 <a:spcPct val="125000"/>
               </a:lnSpc>
               <a:spcBef>
-                <a:spcPts val="200"/>
-              </a:spcBef>
-              <a:spcAft>
-                <a:spcPts val="200"/>
+                <a:spcPts val="0"/>
+              </a:spcBef>
+              <a:spcAft>
+                <a:spcPts val="0"/>
               </a:spcAft>
             </a:pPr>
             <a:r>
@@ -4853,7 +4853,7 @@
                 <a:spcPts val="0"/>
               </a:spcBef>
               <a:spcAft>
-                <a:spcPts val="600"/>
+                <a:spcPts val="0"/>
               </a:spcAft>
             </a:pPr>
             <a:r>
@@ -4872,10 +4872,10 @@
                 <a:spcPct val="125000"/>
               </a:lnSpc>
               <a:spcBef>
-                <a:spcPts val="800"/>
-              </a:spcBef>
-              <a:spcAft>
-                <a:spcPts val="300"/>
+                <a:spcPts val="0"/>
+              </a:spcBef>
+              <a:spcAft>
+                <a:spcPts val="0"/>
               </a:spcAft>
             </a:pPr>
             <a:r>
@@ -4894,10 +4894,10 @@
                 <a:spcPct val="125000"/>
               </a:lnSpc>
               <a:spcBef>
-                <a:spcPts val="200"/>
-              </a:spcBef>
-              <a:spcAft>
-                <a:spcPts val="200"/>
+                <a:spcPts val="0"/>
+              </a:spcBef>
+              <a:spcAft>
+                <a:spcPts val="0"/>
               </a:spcAft>
             </a:pPr>
             <a:r>
@@ -4916,10 +4916,10 @@
                 <a:spcPct val="125000"/>
               </a:lnSpc>
               <a:spcBef>
-                <a:spcPts val="800"/>
-              </a:spcBef>
-              <a:spcAft>
-                <a:spcPts val="300"/>
+                <a:spcPts val="0"/>
+              </a:spcBef>
+              <a:spcAft>
+                <a:spcPts val="0"/>
               </a:spcAft>
             </a:pPr>
             <a:r>
@@ -4938,10 +4938,10 @@
                 <a:spcPct val="125000"/>
               </a:lnSpc>
               <a:spcBef>
-                <a:spcPts val="200"/>
-              </a:spcBef>
-              <a:spcAft>
-                <a:spcPts val="200"/>
+                <a:spcPts val="0"/>
+              </a:spcBef>
+              <a:spcAft>
+                <a:spcPts val="0"/>
               </a:spcAft>
             </a:pPr>
             <a:r>
@@ -4960,10 +4960,10 @@
                 <a:spcPct val="125000"/>
               </a:lnSpc>
               <a:spcBef>
-                <a:spcPts val="200"/>
-              </a:spcBef>
-              <a:spcAft>
-                <a:spcPts val="200"/>
+                <a:spcPts val="0"/>
+              </a:spcBef>
+              <a:spcAft>
+                <a:spcPts val="0"/>
               </a:spcAft>
             </a:pPr>
             <a:r>
@@ -4982,10 +4982,10 @@
                 <a:spcPct val="125000"/>
               </a:lnSpc>
               <a:spcBef>
-                <a:spcPts val="200"/>
-              </a:spcBef>
-              <a:spcAft>
-                <a:spcPts val="200"/>
+                <a:spcPts val="0"/>
+              </a:spcBef>
+              <a:spcAft>
+                <a:spcPts val="0"/>
               </a:spcAft>
             </a:pPr>
             <a:r>
@@ -5004,10 +5004,10 @@
                 <a:spcPct val="125000"/>
               </a:lnSpc>
               <a:spcBef>
-                <a:spcPts val="200"/>
-              </a:spcBef>
-              <a:spcAft>
-                <a:spcPts val="200"/>
+                <a:spcPts val="0"/>
+              </a:spcBef>
+              <a:spcAft>
+                <a:spcPts val="0"/>
               </a:spcAft>
             </a:pPr>
             <a:r>
@@ -5026,10 +5026,10 @@
                 <a:spcPct val="125000"/>
               </a:lnSpc>
               <a:spcBef>
-                <a:spcPts val="800"/>
-              </a:spcBef>
-              <a:spcAft>
-                <a:spcPts val="300"/>
+                <a:spcPts val="0"/>
+              </a:spcBef>
+              <a:spcAft>
+                <a:spcPts val="0"/>
               </a:spcAft>
             </a:pPr>
             <a:r>
@@ -5048,10 +5048,10 @@
                 <a:spcPct val="125000"/>
               </a:lnSpc>
               <a:spcBef>
-                <a:spcPts val="200"/>
-              </a:spcBef>
-              <a:spcAft>
-                <a:spcPts val="200"/>
+                <a:spcPts val="0"/>
+              </a:spcBef>
+              <a:spcAft>
+                <a:spcPts val="0"/>
               </a:spcAft>
             </a:pPr>
             <a:r>
@@ -5070,10 +5070,10 @@
                 <a:spcPct val="125000"/>
               </a:lnSpc>
               <a:spcBef>
-                <a:spcPts val="800"/>
-              </a:spcBef>
-              <a:spcAft>
-                <a:spcPts val="300"/>
+                <a:spcPts val="0"/>
+              </a:spcBef>
+              <a:spcAft>
+                <a:spcPts val="0"/>
               </a:spcAft>
             </a:pPr>
             <a:r>
@@ -5092,10 +5092,10 @@
                 <a:spcPct val="125000"/>
               </a:lnSpc>
               <a:spcBef>
-                <a:spcPts val="200"/>
-              </a:spcBef>
-              <a:spcAft>
-                <a:spcPts val="200"/>
+                <a:spcPts val="0"/>
+              </a:spcBef>
+              <a:spcAft>
+                <a:spcPts val="0"/>
               </a:spcAft>
             </a:pPr>
             <a:r>
@@ -5209,7 +5209,7 @@
                 <a:spcPts val="0"/>
               </a:spcBef>
               <a:spcAft>
-                <a:spcPts val="600"/>
+                <a:spcPts val="0"/>
               </a:spcAft>
             </a:pPr>
             <a:r>
@@ -5228,10 +5228,10 @@
                 <a:spcPct val="125000"/>
               </a:lnSpc>
               <a:spcBef>
-                <a:spcPts val="800"/>
-              </a:spcBef>
-              <a:spcAft>
-                <a:spcPts val="300"/>
+                <a:spcPts val="0"/>
+              </a:spcBef>
+              <a:spcAft>
+                <a:spcPts val="0"/>
               </a:spcAft>
             </a:pPr>
             <a:r>
@@ -5250,10 +5250,10 @@
                 <a:spcPct val="125000"/>
               </a:lnSpc>
               <a:spcBef>
-                <a:spcPts val="200"/>
-              </a:spcBef>
-              <a:spcAft>
-                <a:spcPts val="200"/>
+                <a:spcPts val="0"/>
+              </a:spcBef>
+              <a:spcAft>
+                <a:spcPts val="0"/>
               </a:spcAft>
             </a:pPr>
             <a:r>
@@ -5272,10 +5272,10 @@
                 <a:spcPct val="125000"/>
               </a:lnSpc>
               <a:spcBef>
-                <a:spcPts val="800"/>
-              </a:spcBef>
-              <a:spcAft>
-                <a:spcPts val="300"/>
+                <a:spcPts val="0"/>
+              </a:spcBef>
+              <a:spcAft>
+                <a:spcPts val="0"/>
               </a:spcAft>
             </a:pPr>
             <a:r>
@@ -5294,10 +5294,10 @@
                 <a:spcPct val="125000"/>
               </a:lnSpc>
               <a:spcBef>
-                <a:spcPts val="200"/>
-              </a:spcBef>
-              <a:spcAft>
-                <a:spcPts val="200"/>
+                <a:spcPts val="0"/>
+              </a:spcBef>
+              <a:spcAft>
+                <a:spcPts val="0"/>
               </a:spcAft>
             </a:pPr>
             <a:r>
@@ -5316,10 +5316,10 @@
                 <a:spcPct val="125000"/>
               </a:lnSpc>
               <a:spcBef>
-                <a:spcPts val="200"/>
-              </a:spcBef>
-              <a:spcAft>
-                <a:spcPts val="200"/>
+                <a:spcPts val="0"/>
+              </a:spcBef>
+              <a:spcAft>
+                <a:spcPts val="0"/>
               </a:spcAft>
             </a:pPr>
             <a:r>
@@ -5338,10 +5338,10 @@
                 <a:spcPct val="125000"/>
               </a:lnSpc>
               <a:spcBef>
-                <a:spcPts val="200"/>
-              </a:spcBef>
-              <a:spcAft>
-                <a:spcPts val="200"/>
+                <a:spcPts val="0"/>
+              </a:spcBef>
+              <a:spcAft>
+                <a:spcPts val="0"/>
               </a:spcAft>
             </a:pPr>
             <a:r>
@@ -5360,10 +5360,10 @@
                 <a:spcPct val="125000"/>
               </a:lnSpc>
               <a:spcBef>
-                <a:spcPts val="800"/>
-              </a:spcBef>
-              <a:spcAft>
-                <a:spcPts val="300"/>
+                <a:spcPts val="0"/>
+              </a:spcBef>
+              <a:spcAft>
+                <a:spcPts val="0"/>
               </a:spcAft>
             </a:pPr>
             <a:r>
@@ -5382,10 +5382,10 @@
                 <a:spcPct val="125000"/>
               </a:lnSpc>
               <a:spcBef>
-                <a:spcPts val="200"/>
-              </a:spcBef>
-              <a:spcAft>
-                <a:spcPts val="200"/>
+                <a:spcPts val="0"/>
+              </a:spcBef>
+              <a:spcAft>
+                <a:spcPts val="0"/>
               </a:spcAft>
             </a:pPr>
             <a:r>
@@ -5404,10 +5404,10 @@
                 <a:spcPct val="125000"/>
               </a:lnSpc>
               <a:spcBef>
-                <a:spcPts val="800"/>
-              </a:spcBef>
-              <a:spcAft>
-                <a:spcPts val="300"/>
+                <a:spcPts val="0"/>
+              </a:spcBef>
+              <a:spcAft>
+                <a:spcPts val="0"/>
               </a:spcAft>
             </a:pPr>
             <a:r>
@@ -5426,10 +5426,10 @@
                 <a:spcPct val="125000"/>
               </a:lnSpc>
               <a:spcBef>
-                <a:spcPts val="200"/>
-              </a:spcBef>
-              <a:spcAft>
-                <a:spcPts val="200"/>
+                <a:spcPts val="0"/>
+              </a:spcBef>
+              <a:spcAft>
+                <a:spcPts val="0"/>
               </a:spcAft>
             </a:pPr>
             <a:r>
@@ -5543,7 +5543,7 @@
                 <a:spcPts val="0"/>
               </a:spcBef>
               <a:spcAft>
-                <a:spcPts val="600"/>
+                <a:spcPts val="0"/>
               </a:spcAft>
             </a:pPr>
             <a:r>
@@ -5562,10 +5562,10 @@
                 <a:spcPct val="125000"/>
               </a:lnSpc>
               <a:spcBef>
-                <a:spcPts val="800"/>
-              </a:spcBef>
-              <a:spcAft>
-                <a:spcPts val="300"/>
+                <a:spcPts val="0"/>
+              </a:spcBef>
+              <a:spcAft>
+                <a:spcPts val="0"/>
               </a:spcAft>
             </a:pPr>
             <a:r>
@@ -5584,10 +5584,10 @@
                 <a:spcPct val="125000"/>
               </a:lnSpc>
               <a:spcBef>
-                <a:spcPts val="200"/>
-              </a:spcBef>
-              <a:spcAft>
-                <a:spcPts val="200"/>
+                <a:spcPts val="0"/>
+              </a:spcBef>
+              <a:spcAft>
+                <a:spcPts val="0"/>
               </a:spcAft>
             </a:pPr>
             <a:r>
@@ -5606,10 +5606,10 @@
                 <a:spcPct val="125000"/>
               </a:lnSpc>
               <a:spcBef>
-                <a:spcPts val="800"/>
-              </a:spcBef>
-              <a:spcAft>
-                <a:spcPts val="300"/>
+                <a:spcPts val="0"/>
+              </a:spcBef>
+              <a:spcAft>
+                <a:spcPts val="0"/>
               </a:spcAft>
             </a:pPr>
             <a:r>
@@ -5628,10 +5628,10 @@
                 <a:spcPct val="125000"/>
               </a:lnSpc>
               <a:spcBef>
-                <a:spcPts val="200"/>
-              </a:spcBef>
-              <a:spcAft>
-                <a:spcPts val="200"/>
+                <a:spcPts val="0"/>
+              </a:spcBef>
+              <a:spcAft>
+                <a:spcPts val="0"/>
               </a:spcAft>
             </a:pPr>
             <a:r>
@@ -5650,10 +5650,10 @@
                 <a:spcPct val="125000"/>
               </a:lnSpc>
               <a:spcBef>
-                <a:spcPts val="200"/>
-              </a:spcBef>
-              <a:spcAft>
-                <a:spcPts val="200"/>
+                <a:spcPts val="0"/>
+              </a:spcBef>
+              <a:spcAft>
+                <a:spcPts val="0"/>
               </a:spcAft>
             </a:pPr>
             <a:r>
@@ -5672,10 +5672,10 @@
                 <a:spcPct val="125000"/>
               </a:lnSpc>
               <a:spcBef>
-                <a:spcPts val="800"/>
-              </a:spcBef>
-              <a:spcAft>
-                <a:spcPts val="300"/>
+                <a:spcPts val="0"/>
+              </a:spcBef>
+              <a:spcAft>
+                <a:spcPts val="0"/>
               </a:spcAft>
             </a:pPr>
             <a:r>
@@ -5694,10 +5694,10 @@
                 <a:spcPct val="125000"/>
               </a:lnSpc>
               <a:spcBef>
-                <a:spcPts val="200"/>
-              </a:spcBef>
-              <a:spcAft>
-                <a:spcPts val="200"/>
+                <a:spcPts val="0"/>
+              </a:spcBef>
+              <a:spcAft>
+                <a:spcPts val="0"/>
               </a:spcAft>
             </a:pPr>
             <a:r>
@@ -5716,10 +5716,10 @@
                 <a:spcPct val="125000"/>
               </a:lnSpc>
               <a:spcBef>
-                <a:spcPts val="800"/>
-              </a:spcBef>
-              <a:spcAft>
-                <a:spcPts val="300"/>
+                <a:spcPts val="0"/>
+              </a:spcBef>
+              <a:spcAft>
+                <a:spcPts val="0"/>
               </a:spcAft>
             </a:pPr>
             <a:r>
@@ -5738,10 +5738,10 @@
                 <a:spcPct val="125000"/>
               </a:lnSpc>
               <a:spcBef>
-                <a:spcPts val="200"/>
-              </a:spcBef>
-              <a:spcAft>
-                <a:spcPts val="200"/>
+                <a:spcPts val="0"/>
+              </a:spcBef>
+              <a:spcAft>
+                <a:spcPts val="0"/>
               </a:spcAft>
             </a:pPr>
             <a:r>
@@ -5855,7 +5855,7 @@
                 <a:spcPts val="0"/>
               </a:spcBef>
               <a:spcAft>
-                <a:spcPts val="600"/>
+                <a:spcPts val="0"/>
               </a:spcAft>
             </a:pPr>
             <a:r>
@@ -5874,10 +5874,10 @@
                 <a:spcPct val="125000"/>
               </a:lnSpc>
               <a:spcBef>
-                <a:spcPts val="800"/>
-              </a:spcBef>
-              <a:spcAft>
-                <a:spcPts val="300"/>
+                <a:spcPts val="0"/>
+              </a:spcBef>
+              <a:spcAft>
+                <a:spcPts val="0"/>
               </a:spcAft>
             </a:pPr>
             <a:r>
@@ -5896,10 +5896,10 @@
                 <a:spcPct val="125000"/>
               </a:lnSpc>
               <a:spcBef>
-                <a:spcPts val="200"/>
-              </a:spcBef>
-              <a:spcAft>
-                <a:spcPts val="200"/>
+                <a:spcPts val="0"/>
+              </a:spcBef>
+              <a:spcAft>
+                <a:spcPts val="0"/>
               </a:spcAft>
             </a:pPr>
             <a:r>
@@ -5918,10 +5918,10 @@
                 <a:spcPct val="125000"/>
               </a:lnSpc>
               <a:spcBef>
-                <a:spcPts val="800"/>
-              </a:spcBef>
-              <a:spcAft>
-                <a:spcPts val="300"/>
+                <a:spcPts val="0"/>
+              </a:spcBef>
+              <a:spcAft>
+                <a:spcPts val="0"/>
               </a:spcAft>
             </a:pPr>
             <a:r>
@@ -5940,10 +5940,10 @@
                 <a:spcPct val="125000"/>
               </a:lnSpc>
               <a:spcBef>
-                <a:spcPts val="200"/>
-              </a:spcBef>
-              <a:spcAft>
-                <a:spcPts val="200"/>
+                <a:spcPts val="0"/>
+              </a:spcBef>
+              <a:spcAft>
+                <a:spcPts val="0"/>
               </a:spcAft>
             </a:pPr>
             <a:r>
@@ -5962,10 +5962,10 @@
                 <a:spcPct val="125000"/>
               </a:lnSpc>
               <a:spcBef>
-                <a:spcPts val="200"/>
-              </a:spcBef>
-              <a:spcAft>
-                <a:spcPts val="200"/>
+                <a:spcPts val="0"/>
+              </a:spcBef>
+              <a:spcAft>
+                <a:spcPts val="0"/>
               </a:spcAft>
             </a:pPr>
             <a:r>
@@ -5984,10 +5984,10 @@
                 <a:spcPct val="125000"/>
               </a:lnSpc>
               <a:spcBef>
-                <a:spcPts val="200"/>
-              </a:spcBef>
-              <a:spcAft>
-                <a:spcPts val="200"/>
+                <a:spcPts val="0"/>
+              </a:spcBef>
+              <a:spcAft>
+                <a:spcPts val="0"/>
               </a:spcAft>
             </a:pPr>
             <a:r>
@@ -6006,10 +6006,10 @@
                 <a:spcPct val="125000"/>
               </a:lnSpc>
               <a:spcBef>
-                <a:spcPts val="800"/>
-              </a:spcBef>
-              <a:spcAft>
-                <a:spcPts val="300"/>
+                <a:spcPts val="0"/>
+              </a:spcBef>
+              <a:spcAft>
+                <a:spcPts val="0"/>
               </a:spcAft>
             </a:pPr>
             <a:r>
@@ -6028,10 +6028,10 @@
                 <a:spcPct val="125000"/>
               </a:lnSpc>
               <a:spcBef>
-                <a:spcPts val="200"/>
-              </a:spcBef>
-              <a:spcAft>
-                <a:spcPts val="200"/>
+                <a:spcPts val="0"/>
+              </a:spcBef>
+              <a:spcAft>
+                <a:spcPts val="0"/>
               </a:spcAft>
             </a:pPr>
             <a:r>
@@ -6050,10 +6050,10 @@
                 <a:spcPct val="125000"/>
               </a:lnSpc>
               <a:spcBef>
-                <a:spcPts val="800"/>
-              </a:spcBef>
-              <a:spcAft>
-                <a:spcPts val="300"/>
+                <a:spcPts val="0"/>
+              </a:spcBef>
+              <a:spcAft>
+                <a:spcPts val="0"/>
               </a:spcAft>
             </a:pPr>
             <a:r>
@@ -6072,10 +6072,10 @@
                 <a:spcPct val="125000"/>
               </a:lnSpc>
               <a:spcBef>
-                <a:spcPts val="200"/>
-              </a:spcBef>
-              <a:spcAft>
-                <a:spcPts val="200"/>
+                <a:spcPts val="0"/>
+              </a:spcBef>
+              <a:spcAft>
+                <a:spcPts val="0"/>
               </a:spcAft>
             </a:pPr>
             <a:r>
@@ -6189,7 +6189,7 @@
                 <a:spcPts val="0"/>
               </a:spcBef>
               <a:spcAft>
-                <a:spcPts val="600"/>
+                <a:spcPts val="0"/>
               </a:spcAft>
             </a:pPr>
             <a:r>
@@ -6208,10 +6208,10 @@
                 <a:spcPct val="125000"/>
               </a:lnSpc>
               <a:spcBef>
-                <a:spcPts val="800"/>
-              </a:spcBef>
-              <a:spcAft>
-                <a:spcPts val="300"/>
+                <a:spcPts val="0"/>
+              </a:spcBef>
+              <a:spcAft>
+                <a:spcPts val="0"/>
               </a:spcAft>
             </a:pPr>
             <a:r>
@@ -6230,10 +6230,10 @@
                 <a:spcPct val="125000"/>
               </a:lnSpc>
               <a:spcBef>
-                <a:spcPts val="200"/>
-              </a:spcBef>
-              <a:spcAft>
-                <a:spcPts val="200"/>
+                <a:spcPts val="0"/>
+              </a:spcBef>
+              <a:spcAft>
+                <a:spcPts val="0"/>
               </a:spcAft>
             </a:pPr>
             <a:r>
@@ -6252,10 +6252,10 @@
                 <a:spcPct val="125000"/>
               </a:lnSpc>
               <a:spcBef>
-                <a:spcPts val="800"/>
-              </a:spcBef>
-              <a:spcAft>
-                <a:spcPts val="300"/>
+                <a:spcPts val="0"/>
+              </a:spcBef>
+              <a:spcAft>
+                <a:spcPts val="0"/>
               </a:spcAft>
             </a:pPr>
             <a:r>
@@ -6274,10 +6274,10 @@
                 <a:spcPct val="125000"/>
               </a:lnSpc>
               <a:spcBef>
-                <a:spcPts val="200"/>
-              </a:spcBef>
-              <a:spcAft>
-                <a:spcPts val="200"/>
+                <a:spcPts val="0"/>
+              </a:spcBef>
+              <a:spcAft>
+                <a:spcPts val="0"/>
               </a:spcAft>
             </a:pPr>
             <a:r>
@@ -6296,10 +6296,10 @@
                 <a:spcPct val="125000"/>
               </a:lnSpc>
               <a:spcBef>
-                <a:spcPts val="200"/>
-              </a:spcBef>
-              <a:spcAft>
-                <a:spcPts val="200"/>
+                <a:spcPts val="0"/>
+              </a:spcBef>
+              <a:spcAft>
+                <a:spcPts val="0"/>
               </a:spcAft>
             </a:pPr>
             <a:r>
@@ -6318,10 +6318,10 @@
                 <a:spcPct val="125000"/>
               </a:lnSpc>
               <a:spcBef>
-                <a:spcPts val="200"/>
-              </a:spcBef>
-              <a:spcAft>
-                <a:spcPts val="200"/>
+                <a:spcPts val="0"/>
+              </a:spcBef>
+              <a:spcAft>
+                <a:spcPts val="0"/>
               </a:spcAft>
             </a:pPr>
             <a:r>
@@ -6340,10 +6340,10 @@
                 <a:spcPct val="125000"/>
               </a:lnSpc>
               <a:spcBef>
-                <a:spcPts val="200"/>
-              </a:spcBef>
-              <a:spcAft>
-                <a:spcPts val="200"/>
+                <a:spcPts val="0"/>
+              </a:spcBef>
+              <a:spcAft>
+                <a:spcPts val="0"/>
               </a:spcAft>
             </a:pPr>
             <a:r>
@@ -6362,10 +6362,10 @@
                 <a:spcPct val="125000"/>
               </a:lnSpc>
               <a:spcBef>
-                <a:spcPts val="800"/>
-              </a:spcBef>
-              <a:spcAft>
-                <a:spcPts val="300"/>
+                <a:spcPts val="0"/>
+              </a:spcBef>
+              <a:spcAft>
+                <a:spcPts val="0"/>
               </a:spcAft>
             </a:pPr>
             <a:r>
@@ -6384,10 +6384,10 @@
                 <a:spcPct val="125000"/>
               </a:lnSpc>
               <a:spcBef>
-                <a:spcPts val="200"/>
-              </a:spcBef>
-              <a:spcAft>
-                <a:spcPts val="200"/>
+                <a:spcPts val="0"/>
+              </a:spcBef>
+              <a:spcAft>
+                <a:spcPts val="0"/>
               </a:spcAft>
             </a:pPr>
             <a:r>
@@ -6406,10 +6406,10 @@
                 <a:spcPct val="125000"/>
               </a:lnSpc>
               <a:spcBef>
-                <a:spcPts val="800"/>
-              </a:spcBef>
-              <a:spcAft>
-                <a:spcPts val="300"/>
+                <a:spcPts val="0"/>
+              </a:spcBef>
+              <a:spcAft>
+                <a:spcPts val="0"/>
               </a:spcAft>
             </a:pPr>
             <a:r>
@@ -6428,10 +6428,10 @@
                 <a:spcPct val="125000"/>
               </a:lnSpc>
               <a:spcBef>
-                <a:spcPts val="200"/>
-              </a:spcBef>
-              <a:spcAft>
-                <a:spcPts val="200"/>
+                <a:spcPts val="0"/>
+              </a:spcBef>
+              <a:spcAft>
+                <a:spcPts val="0"/>
               </a:spcAft>
             </a:pPr>
             <a:r>
@@ -6545,7 +6545,7 @@
                 <a:spcPts val="0"/>
               </a:spcBef>
               <a:spcAft>
-                <a:spcPts val="600"/>
+                <a:spcPts val="0"/>
               </a:spcAft>
             </a:pPr>
             <a:r>
@@ -6564,10 +6564,10 @@
                 <a:spcPct val="125000"/>
               </a:lnSpc>
               <a:spcBef>
-                <a:spcPts val="800"/>
-              </a:spcBef>
-              <a:spcAft>
-                <a:spcPts val="300"/>
+                <a:spcPts val="0"/>
+              </a:spcBef>
+              <a:spcAft>
+                <a:spcPts val="0"/>
               </a:spcAft>
             </a:pPr>
             <a:r>
@@ -6586,10 +6586,10 @@
                 <a:spcPct val="125000"/>
               </a:lnSpc>
               <a:spcBef>
-                <a:spcPts val="200"/>
-              </a:spcBef>
-              <a:spcAft>
-                <a:spcPts val="200"/>
+                <a:spcPts val="0"/>
+              </a:spcBef>
+              <a:spcAft>
+                <a:spcPts val="0"/>
               </a:spcAft>
             </a:pPr>
             <a:r>
@@ -6608,10 +6608,10 @@
                 <a:spcPct val="125000"/>
               </a:lnSpc>
               <a:spcBef>
-                <a:spcPts val="800"/>
-              </a:spcBef>
-              <a:spcAft>
-                <a:spcPts val="300"/>
+                <a:spcPts val="0"/>
+              </a:spcBef>
+              <a:spcAft>
+                <a:spcPts val="0"/>
               </a:spcAft>
             </a:pPr>
             <a:r>
@@ -6630,10 +6630,10 @@
                 <a:spcPct val="125000"/>
               </a:lnSpc>
               <a:spcBef>
-                <a:spcPts val="200"/>
-              </a:spcBef>
-              <a:spcAft>
-                <a:spcPts val="200"/>
+                <a:spcPts val="0"/>
+              </a:spcBef>
+              <a:spcAft>
+                <a:spcPts val="0"/>
               </a:spcAft>
             </a:pPr>
             <a:r>
@@ -6652,10 +6652,10 @@
                 <a:spcPct val="125000"/>
               </a:lnSpc>
               <a:spcBef>
-                <a:spcPts val="200"/>
-              </a:spcBef>
-              <a:spcAft>
-                <a:spcPts val="200"/>
+                <a:spcPts val="0"/>
+              </a:spcBef>
+              <a:spcAft>
+                <a:spcPts val="0"/>
               </a:spcAft>
             </a:pPr>
             <a:r>
@@ -6674,10 +6674,10 @@
                 <a:spcPct val="125000"/>
               </a:lnSpc>
               <a:spcBef>
-                <a:spcPts val="200"/>
-              </a:spcBef>
-              <a:spcAft>
-                <a:spcPts val="200"/>
+                <a:spcPts val="0"/>
+              </a:spcBef>
+              <a:spcAft>
+                <a:spcPts val="0"/>
               </a:spcAft>
             </a:pPr>
             <a:r>
@@ -6696,10 +6696,10 @@
                 <a:spcPct val="125000"/>
               </a:lnSpc>
               <a:spcBef>
-                <a:spcPts val="200"/>
-              </a:spcBef>
-              <a:spcAft>
-                <a:spcPts val="200"/>
+                <a:spcPts val="0"/>
+              </a:spcBef>
+              <a:spcAft>
+                <a:spcPts val="0"/>
               </a:spcAft>
             </a:pPr>
             <a:r>
@@ -6718,10 +6718,10 @@
                 <a:spcPct val="125000"/>
               </a:lnSpc>
               <a:spcBef>
-                <a:spcPts val="800"/>
-              </a:spcBef>
-              <a:spcAft>
-                <a:spcPts val="300"/>
+                <a:spcPts val="0"/>
+              </a:spcBef>
+              <a:spcAft>
+                <a:spcPts val="0"/>
               </a:spcAft>
             </a:pPr>
             <a:r>
@@ -6740,10 +6740,10 @@
                 <a:spcPct val="125000"/>
               </a:lnSpc>
               <a:spcBef>
-                <a:spcPts val="200"/>
-              </a:spcBef>
-              <a:spcAft>
-                <a:spcPts val="200"/>
+                <a:spcPts val="0"/>
+              </a:spcBef>
+              <a:spcAft>
+                <a:spcPts val="0"/>
               </a:spcAft>
             </a:pPr>
             <a:r>
@@ -6762,10 +6762,10 @@
                 <a:spcPct val="125000"/>
               </a:lnSpc>
               <a:spcBef>
-                <a:spcPts val="800"/>
-              </a:spcBef>
-              <a:spcAft>
-                <a:spcPts val="300"/>
+                <a:spcPts val="0"/>
+              </a:spcBef>
+              <a:spcAft>
+                <a:spcPts val="0"/>
               </a:spcAft>
             </a:pPr>
             <a:r>
@@ -6784,10 +6784,10 @@
                 <a:spcPct val="125000"/>
               </a:lnSpc>
               <a:spcBef>
-                <a:spcPts val="200"/>
-              </a:spcBef>
-              <a:spcAft>
-                <a:spcPts val="200"/>
+                <a:spcPts val="0"/>
+              </a:spcBef>
+              <a:spcAft>
+                <a:spcPts val="0"/>
               </a:spcAft>
             </a:pPr>
             <a:r>
@@ -6901,7 +6901,7 @@
                 <a:spcPts val="0"/>
               </a:spcBef>
               <a:spcAft>
-                <a:spcPts val="600"/>
+                <a:spcPts val="0"/>
               </a:spcAft>
             </a:pPr>
             <a:r>
@@ -6920,10 +6920,10 @@
                 <a:spcPct val="125000"/>
               </a:lnSpc>
               <a:spcBef>
-                <a:spcPts val="800"/>
-              </a:spcBef>
-              <a:spcAft>
-                <a:spcPts val="300"/>
+                <a:spcPts val="0"/>
+              </a:spcBef>
+              <a:spcAft>
+                <a:spcPts val="0"/>
               </a:spcAft>
             </a:pPr>
             <a:r>
@@ -6942,10 +6942,10 @@
                 <a:spcPct val="125000"/>
               </a:lnSpc>
               <a:spcBef>
-                <a:spcPts val="200"/>
-              </a:spcBef>
-              <a:spcAft>
-                <a:spcPts val="200"/>
+                <a:spcPts val="0"/>
+              </a:spcBef>
+              <a:spcAft>
+                <a:spcPts val="0"/>
               </a:spcAft>
             </a:pPr>
             <a:r>
@@ -6964,10 +6964,10 @@
                 <a:spcPct val="125000"/>
               </a:lnSpc>
               <a:spcBef>
-                <a:spcPts val="800"/>
-              </a:spcBef>
-              <a:spcAft>
-                <a:spcPts val="300"/>
+                <a:spcPts val="0"/>
+              </a:spcBef>
+              <a:spcAft>
+                <a:spcPts val="0"/>
               </a:spcAft>
             </a:pPr>
             <a:r>
@@ -6986,10 +6986,10 @@
                 <a:spcPct val="125000"/>
               </a:lnSpc>
               <a:spcBef>
-                <a:spcPts val="200"/>
-              </a:spcBef>
-              <a:spcAft>
-                <a:spcPts val="200"/>
+                <a:spcPts val="0"/>
+              </a:spcBef>
+              <a:spcAft>
+                <a:spcPts val="0"/>
               </a:spcAft>
             </a:pPr>
             <a:r>
@@ -7008,10 +7008,10 @@
                 <a:spcPct val="125000"/>
               </a:lnSpc>
               <a:spcBef>
-                <a:spcPts val="200"/>
-              </a:spcBef>
-              <a:spcAft>
-                <a:spcPts val="200"/>
+                <a:spcPts val="0"/>
+              </a:spcBef>
+              <a:spcAft>
+                <a:spcPts val="0"/>
               </a:spcAft>
             </a:pPr>
             <a:r>
@@ -7030,10 +7030,10 @@
                 <a:spcPct val="125000"/>
               </a:lnSpc>
               <a:spcBef>
-                <a:spcPts val="200"/>
-              </a:spcBef>
-              <a:spcAft>
-                <a:spcPts val="200"/>
+                <a:spcPts val="0"/>
+              </a:spcBef>
+              <a:spcAft>
+                <a:spcPts val="0"/>
               </a:spcAft>
             </a:pPr>
             <a:r>
@@ -7052,10 +7052,10 @@
                 <a:spcPct val="125000"/>
               </a:lnSpc>
               <a:spcBef>
-                <a:spcPts val="200"/>
-              </a:spcBef>
-              <a:spcAft>
-                <a:spcPts val="200"/>
+                <a:spcPts val="0"/>
+              </a:spcBef>
+              <a:spcAft>
+                <a:spcPts val="0"/>
               </a:spcAft>
             </a:pPr>
             <a:r>
@@ -7074,10 +7074,10 @@
                 <a:spcPct val="125000"/>
               </a:lnSpc>
               <a:spcBef>
-                <a:spcPts val="800"/>
-              </a:spcBef>
-              <a:spcAft>
-                <a:spcPts val="300"/>
+                <a:spcPts val="0"/>
+              </a:spcBef>
+              <a:spcAft>
+                <a:spcPts val="0"/>
               </a:spcAft>
             </a:pPr>
             <a:r>
@@ -7096,10 +7096,10 @@
                 <a:spcPct val="125000"/>
               </a:lnSpc>
               <a:spcBef>
-                <a:spcPts val="200"/>
-              </a:spcBef>
-              <a:spcAft>
-                <a:spcPts val="200"/>
+                <a:spcPts val="0"/>
+              </a:spcBef>
+              <a:spcAft>
+                <a:spcPts val="0"/>
               </a:spcAft>
             </a:pPr>
             <a:r>
@@ -7118,10 +7118,10 @@
                 <a:spcPct val="125000"/>
               </a:lnSpc>
               <a:spcBef>
-                <a:spcPts val="800"/>
-              </a:spcBef>
-              <a:spcAft>
-                <a:spcPts val="300"/>
+                <a:spcPts val="0"/>
+              </a:spcBef>
+              <a:spcAft>
+                <a:spcPts val="0"/>
               </a:spcAft>
             </a:pPr>
             <a:r>
@@ -7140,10 +7140,10 @@
                 <a:spcPct val="125000"/>
               </a:lnSpc>
               <a:spcBef>
-                <a:spcPts val="200"/>
-              </a:spcBef>
-              <a:spcAft>
-                <a:spcPts val="200"/>
+                <a:spcPts val="0"/>
+              </a:spcBef>
+              <a:spcAft>
+                <a:spcPts val="0"/>
               </a:spcAft>
             </a:pPr>
             <a:r>
@@ -7257,7 +7257,7 @@
                 <a:spcPts val="0"/>
               </a:spcBef>
               <a:spcAft>
-                <a:spcPts val="600"/>
+                <a:spcPts val="0"/>
               </a:spcAft>
             </a:pPr>
             <a:r>
@@ -7276,10 +7276,10 @@
                 <a:spcPct val="125000"/>
               </a:lnSpc>
               <a:spcBef>
-                <a:spcPts val="800"/>
-              </a:spcBef>
-              <a:spcAft>
-                <a:spcPts val="300"/>
+                <a:spcPts val="0"/>
+              </a:spcBef>
+              <a:spcAft>
+                <a:spcPts val="0"/>
               </a:spcAft>
             </a:pPr>
             <a:r>
@@ -7298,10 +7298,10 @@
                 <a:spcPct val="125000"/>
               </a:lnSpc>
               <a:spcBef>
-                <a:spcPts val="200"/>
-              </a:spcBef>
-              <a:spcAft>
-                <a:spcPts val="200"/>
+                <a:spcPts val="0"/>
+              </a:spcBef>
+              <a:spcAft>
+                <a:spcPts val="0"/>
               </a:spcAft>
             </a:pPr>
             <a:r>
@@ -7320,10 +7320,10 @@
                 <a:spcPct val="125000"/>
               </a:lnSpc>
               <a:spcBef>
-                <a:spcPts val="800"/>
-              </a:spcBef>
-              <a:spcAft>
-                <a:spcPts val="300"/>
+                <a:spcPts val="0"/>
+              </a:spcBef>
+              <a:spcAft>
+                <a:spcPts val="0"/>
               </a:spcAft>
             </a:pPr>
             <a:r>
@@ -7342,10 +7342,10 @@
                 <a:spcPct val="125000"/>
               </a:lnSpc>
               <a:spcBef>
-                <a:spcPts val="200"/>
-              </a:spcBef>
-              <a:spcAft>
-                <a:spcPts val="200"/>
+                <a:spcPts val="0"/>
+              </a:spcBef>
+              <a:spcAft>
+                <a:spcPts val="0"/>
               </a:spcAft>
             </a:pPr>
             <a:r>
@@ -7364,10 +7364,10 @@
                 <a:spcPct val="125000"/>
               </a:lnSpc>
               <a:spcBef>
-                <a:spcPts val="200"/>
-              </a:spcBef>
-              <a:spcAft>
-                <a:spcPts val="200"/>
+                <a:spcPts val="0"/>
+              </a:spcBef>
+              <a:spcAft>
+                <a:spcPts val="0"/>
               </a:spcAft>
             </a:pPr>
             <a:r>
@@ -7386,10 +7386,10 @@
                 <a:spcPct val="125000"/>
               </a:lnSpc>
               <a:spcBef>
-                <a:spcPts val="200"/>
-              </a:spcBef>
-              <a:spcAft>
-                <a:spcPts val="200"/>
+                <a:spcPts val="0"/>
+              </a:spcBef>
+              <a:spcAft>
+                <a:spcPts val="0"/>
               </a:spcAft>
             </a:pPr>
             <a:r>
@@ -7408,10 +7408,10 @@
                 <a:spcPct val="125000"/>
               </a:lnSpc>
               <a:spcBef>
-                <a:spcPts val="200"/>
-              </a:spcBef>
-              <a:spcAft>
-                <a:spcPts val="200"/>
+                <a:spcPts val="0"/>
+              </a:spcBef>
+              <a:spcAft>
+                <a:spcPts val="0"/>
               </a:spcAft>
             </a:pPr>
             <a:r>
@@ -7430,10 +7430,10 @@
                 <a:spcPct val="125000"/>
               </a:lnSpc>
               <a:spcBef>
-                <a:spcPts val="800"/>
-              </a:spcBef>
-              <a:spcAft>
-                <a:spcPts val="300"/>
+                <a:spcPts val="0"/>
+              </a:spcBef>
+              <a:spcAft>
+                <a:spcPts val="0"/>
               </a:spcAft>
             </a:pPr>
             <a:r>
@@ -7452,10 +7452,10 @@
                 <a:spcPct val="125000"/>
               </a:lnSpc>
               <a:spcBef>
-                <a:spcPts val="200"/>
-              </a:spcBef>
-              <a:spcAft>
-                <a:spcPts val="200"/>
+                <a:spcPts val="0"/>
+              </a:spcBef>
+              <a:spcAft>
+                <a:spcPts val="0"/>
               </a:spcAft>
             </a:pPr>
             <a:r>
@@ -7474,10 +7474,10 @@
                 <a:spcPct val="125000"/>
               </a:lnSpc>
               <a:spcBef>
-                <a:spcPts val="800"/>
-              </a:spcBef>
-              <a:spcAft>
-                <a:spcPts val="300"/>
+                <a:spcPts val="0"/>
+              </a:spcBef>
+              <a:spcAft>
+                <a:spcPts val="0"/>
               </a:spcAft>
             </a:pPr>
             <a:r>
@@ -7496,10 +7496,10 @@
                 <a:spcPct val="125000"/>
               </a:lnSpc>
               <a:spcBef>
-                <a:spcPts val="200"/>
-              </a:spcBef>
-              <a:spcAft>
-                <a:spcPts val="200"/>
+                <a:spcPts val="0"/>
+              </a:spcBef>
+              <a:spcAft>
+                <a:spcPts val="0"/>
               </a:spcAft>
             </a:pPr>
             <a:r>
@@ -7613,7 +7613,7 @@
                 <a:spcPts val="0"/>
               </a:spcBef>
               <a:spcAft>
-                <a:spcPts val="600"/>
+                <a:spcPts val="0"/>
               </a:spcAft>
             </a:pPr>
             <a:r>
@@ -7632,10 +7632,10 @@
                 <a:spcPct val="125000"/>
               </a:lnSpc>
               <a:spcBef>
-                <a:spcPts val="800"/>
-              </a:spcBef>
-              <a:spcAft>
-                <a:spcPts val="300"/>
+                <a:spcPts val="0"/>
+              </a:spcBef>
+              <a:spcAft>
+                <a:spcPts val="0"/>
               </a:spcAft>
             </a:pPr>
             <a:r>
@@ -7654,10 +7654,10 @@
                 <a:spcPct val="125000"/>
               </a:lnSpc>
               <a:spcBef>
-                <a:spcPts val="200"/>
-              </a:spcBef>
-              <a:spcAft>
-                <a:spcPts val="200"/>
+                <a:spcPts val="0"/>
+              </a:spcBef>
+              <a:spcAft>
+                <a:spcPts val="0"/>
               </a:spcAft>
             </a:pPr>
             <a:r>
@@ -7676,10 +7676,10 @@
                 <a:spcPct val="125000"/>
               </a:lnSpc>
               <a:spcBef>
-                <a:spcPts val="800"/>
-              </a:spcBef>
-              <a:spcAft>
-                <a:spcPts val="300"/>
+                <a:spcPts val="0"/>
+              </a:spcBef>
+              <a:spcAft>
+                <a:spcPts val="0"/>
               </a:spcAft>
             </a:pPr>
             <a:r>
@@ -7698,10 +7698,10 @@
                 <a:spcPct val="125000"/>
               </a:lnSpc>
               <a:spcBef>
-                <a:spcPts val="200"/>
-              </a:spcBef>
-              <a:spcAft>
-                <a:spcPts val="200"/>
+                <a:spcPts val="0"/>
+              </a:spcBef>
+              <a:spcAft>
+                <a:spcPts val="0"/>
               </a:spcAft>
             </a:pPr>
             <a:r>
@@ -7720,10 +7720,10 @@
                 <a:spcPct val="125000"/>
               </a:lnSpc>
               <a:spcBef>
-                <a:spcPts val="200"/>
-              </a:spcBef>
-              <a:spcAft>
-                <a:spcPts val="200"/>
+                <a:spcPts val="0"/>
+              </a:spcBef>
+              <a:spcAft>
+                <a:spcPts val="0"/>
               </a:spcAft>
             </a:pPr>
             <a:r>
@@ -7742,10 +7742,10 @@
                 <a:spcPct val="125000"/>
               </a:lnSpc>
               <a:spcBef>
-                <a:spcPts val="200"/>
-              </a:spcBef>
-              <a:spcAft>
-                <a:spcPts val="200"/>
+                <a:spcPts val="0"/>
+              </a:spcBef>
+              <a:spcAft>
+                <a:spcPts val="0"/>
               </a:spcAft>
             </a:pPr>
             <a:r>
@@ -7764,10 +7764,10 @@
                 <a:spcPct val="125000"/>
               </a:lnSpc>
               <a:spcBef>
-                <a:spcPts val="800"/>
-              </a:spcBef>
-              <a:spcAft>
-                <a:spcPts val="300"/>
+                <a:spcPts val="0"/>
+              </a:spcBef>
+              <a:spcAft>
+                <a:spcPts val="0"/>
               </a:spcAft>
             </a:pPr>
             <a:r>
@@ -7786,10 +7786,10 @@
                 <a:spcPct val="125000"/>
               </a:lnSpc>
               <a:spcBef>
-                <a:spcPts val="200"/>
-              </a:spcBef>
-              <a:spcAft>
-                <a:spcPts val="200"/>
+                <a:spcPts val="0"/>
+              </a:spcBef>
+              <a:spcAft>
+                <a:spcPts val="0"/>
               </a:spcAft>
             </a:pPr>
             <a:r>
@@ -7808,10 +7808,10 @@
                 <a:spcPct val="125000"/>
               </a:lnSpc>
               <a:spcBef>
-                <a:spcPts val="800"/>
-              </a:spcBef>
-              <a:spcAft>
-                <a:spcPts val="300"/>
+                <a:spcPts val="0"/>
+              </a:spcBef>
+              <a:spcAft>
+                <a:spcPts val="0"/>
               </a:spcAft>
             </a:pPr>
             <a:r>
@@ -7830,10 +7830,10 @@
                 <a:spcPct val="125000"/>
               </a:lnSpc>
               <a:spcBef>
-                <a:spcPts val="200"/>
-              </a:spcBef>
-              <a:spcAft>
-                <a:spcPts val="200"/>
+                <a:spcPts val="0"/>
+              </a:spcBef>
+              <a:spcAft>
+                <a:spcPts val="0"/>
               </a:spcAft>
             </a:pPr>
             <a:r>
@@ -7947,7 +7947,7 @@
                 <a:spcPts val="0"/>
               </a:spcBef>
               <a:spcAft>
-                <a:spcPts val="600"/>
+                <a:spcPts val="0"/>
               </a:spcAft>
             </a:pPr>
             <a:r>
@@ -7966,10 +7966,10 @@
                 <a:spcPct val="125000"/>
               </a:lnSpc>
               <a:spcBef>
-                <a:spcPts val="800"/>
-              </a:spcBef>
-              <a:spcAft>
-                <a:spcPts val="300"/>
+                <a:spcPts val="0"/>
+              </a:spcBef>
+              <a:spcAft>
+                <a:spcPts val="0"/>
               </a:spcAft>
             </a:pPr>
             <a:r>
@@ -7988,10 +7988,10 @@
                 <a:spcPct val="125000"/>
               </a:lnSpc>
               <a:spcBef>
-                <a:spcPts val="200"/>
-              </a:spcBef>
-              <a:spcAft>
-                <a:spcPts val="200"/>
+                <a:spcPts val="0"/>
+              </a:spcBef>
+              <a:spcAft>
+                <a:spcPts val="0"/>
               </a:spcAft>
             </a:pPr>
             <a:r>
@@ -8010,10 +8010,10 @@
                 <a:spcPct val="125000"/>
               </a:lnSpc>
               <a:spcBef>
-                <a:spcPts val="800"/>
-              </a:spcBef>
-              <a:spcAft>
-                <a:spcPts val="300"/>
+                <a:spcPts val="0"/>
+              </a:spcBef>
+              <a:spcAft>
+                <a:spcPts val="0"/>
               </a:spcAft>
             </a:pPr>
             <a:r>
@@ -8032,10 +8032,10 @@
                 <a:spcPct val="125000"/>
               </a:lnSpc>
               <a:spcBef>
-                <a:spcPts val="200"/>
-              </a:spcBef>
-              <a:spcAft>
-                <a:spcPts val="200"/>
+                <a:spcPts val="0"/>
+              </a:spcBef>
+              <a:spcAft>
+                <a:spcPts val="0"/>
               </a:spcAft>
             </a:pPr>
             <a:r>
@@ -8054,10 +8054,10 @@
                 <a:spcPct val="125000"/>
               </a:lnSpc>
               <a:spcBef>
-                <a:spcPts val="200"/>
-              </a:spcBef>
-              <a:spcAft>
-                <a:spcPts val="200"/>
+                <a:spcPts val="0"/>
+              </a:spcBef>
+              <a:spcAft>
+                <a:spcPts val="0"/>
               </a:spcAft>
             </a:pPr>
             <a:r>
@@ -8076,10 +8076,10 @@
                 <a:spcPct val="125000"/>
               </a:lnSpc>
               <a:spcBef>
-                <a:spcPts val="200"/>
-              </a:spcBef>
-              <a:spcAft>
-                <a:spcPts val="200"/>
+                <a:spcPts val="0"/>
+              </a:spcBef>
+              <a:spcAft>
+                <a:spcPts val="0"/>
               </a:spcAft>
             </a:pPr>
             <a:r>
@@ -8098,10 +8098,10 @@
                 <a:spcPct val="125000"/>
               </a:lnSpc>
               <a:spcBef>
-                <a:spcPts val="200"/>
-              </a:spcBef>
-              <a:spcAft>
-                <a:spcPts val="200"/>
+                <a:spcPts val="0"/>
+              </a:spcBef>
+              <a:spcAft>
+                <a:spcPts val="0"/>
               </a:spcAft>
             </a:pPr>
             <a:r>
@@ -8120,10 +8120,10 @@
                 <a:spcPct val="125000"/>
               </a:lnSpc>
               <a:spcBef>
-                <a:spcPts val="800"/>
-              </a:spcBef>
-              <a:spcAft>
-                <a:spcPts val="300"/>
+                <a:spcPts val="0"/>
+              </a:spcBef>
+              <a:spcAft>
+                <a:spcPts val="0"/>
               </a:spcAft>
             </a:pPr>
             <a:r>
@@ -8142,10 +8142,10 @@
                 <a:spcPct val="125000"/>
               </a:lnSpc>
               <a:spcBef>
-                <a:spcPts val="200"/>
-              </a:spcBef>
-              <a:spcAft>
-                <a:spcPts val="200"/>
+                <a:spcPts val="0"/>
+              </a:spcBef>
+              <a:spcAft>
+                <a:spcPts val="0"/>
               </a:spcAft>
             </a:pPr>
             <a:r>
@@ -8164,10 +8164,10 @@
                 <a:spcPct val="125000"/>
               </a:lnSpc>
               <a:spcBef>
-                <a:spcPts val="800"/>
-              </a:spcBef>
-              <a:spcAft>
-                <a:spcPts val="300"/>
+                <a:spcPts val="0"/>
+              </a:spcBef>
+              <a:spcAft>
+                <a:spcPts val="0"/>
               </a:spcAft>
             </a:pPr>
             <a:r>
@@ -8186,10 +8186,10 @@
                 <a:spcPct val="125000"/>
               </a:lnSpc>
               <a:spcBef>
-                <a:spcPts val="200"/>
-              </a:spcBef>
-              <a:spcAft>
-                <a:spcPts val="200"/>
+                <a:spcPts val="0"/>
+              </a:spcBef>
+              <a:spcAft>
+                <a:spcPts val="0"/>
               </a:spcAft>
             </a:pPr>
             <a:r>

</xml_diff>